<commit_message>
Redesign executive slide in reference navy-cyan style with exact sheet 5 content
</commit_message>
<xml_diff>
--- a/Neiv_CS13_Slide.pptx
+++ b/Neiv_CS13_Slide.pptx
@@ -2,13 +2,13 @@
 <file path=ppt/presentation.xml><?xml version="1.0" encoding="utf-8"?>
 <p:presentation xmlns:p="http://schemas.openxmlformats.org/presentationml/2006/main">
   <p:sldMasterIdLst>
-    <p:sldMasterId xmlns:r="http://schemas.openxmlformats.org/officeDocument/2006/relationships" id="2147483648" r:id="R9c8a4b0e3c4a4d29"/>
+    <p:sldMasterId xmlns:r="http://schemas.openxmlformats.org/officeDocument/2006/relationships" id="2147483648" r:id="R67359057c3994569"/>
   </p:sldMasterIdLst>
   <p:notesMasterIdLst>
-    <p:notesMasterId xmlns:r="http://schemas.openxmlformats.org/officeDocument/2006/relationships" r:id="R6f9767d6d4774954"/>
+    <p:notesMasterId xmlns:r="http://schemas.openxmlformats.org/officeDocument/2006/relationships" r:id="Rfc23e53a47304ca9"/>
   </p:notesMasterIdLst>
   <p:sldIdLst>
-    <p:sldId xmlns:r="http://schemas.openxmlformats.org/officeDocument/2006/relationships" id="256" r:id="R38fc14490a35444b"/>
+    <p:sldId xmlns:r="http://schemas.openxmlformats.org/officeDocument/2006/relationships" id="256" r:id="R113e613e538f4c62"/>
   </p:sldIdLst>
   <p:sldSz cx="15240000" cy="8572500"/>
   <p:notesSz cx="6858000" cy="9144000"/>
@@ -442,7 +442,7 @@
           <a:lstStyle xmlns:a="http://schemas.openxmlformats.org/drawingml/2006/main"/>
           <a:p xmlns:a="http://schemas.openxmlformats.org/drawingml/2006/main">
             <a:r>
-              <a:t>Nguồn: docs/CS13_HoSoTinhHuong.pdf, Đề 1, trang 2–3; docs/CS13_SlideLop_AIRoadmap.pdf, slide 74 và 81–85. Nội dung tương ứng chính xác 5_Slide lãnh đạo!B4:B8 trong Neiv_CS13.xlsx. Tất cả số liệu hồ sơ là tình huống giả định. Ngưỡng thử nghiệm bổ sung là đề xuất, chưa phải kết quả đo. Biên Mức 1=(3.970.000−1.760×704)/3.970.000=68,79%. Duyệt 20%×12.000×1,5/60=60 giờ/tháng, là nhân sự công ty, tách giờ chuyên gia. Giờ Tùng và phí tích hợp cần xác nhận. Không có cam kết tuyển đủ 10 văn phòng trong 90 ngày. Ngày 30/60/90 tính từ ngày bắt đầu triển khai được thống nhất, không phải ngày nộp lab.</a:t>
+              <a:t>Nội dung nguyên văn từ Neiv_CS13.xlsx, trang 5_Slide lãnh đạo, B4:B8. B5 được tách theo 3 câu để đưa vào sơ đồ lộ trình. Nguồn: docs/CS13_HoSoTinhHuong.pdf, Đề 1, trang 2–3; docs/CS13_SlideLop_AIRoadmap.pdf, slide 74 và 81–85. Tất cả số liệu hồ sơ là giả định. Ngưỡng bổ sung là đề xuất cần kiểm chứng. Tham khảo phong cách ảnh người dùng cung cấp ngày 16/10/2026: nền trắng, navy/cyan, tiêu đề lớn, khung viền mảnh, sơ đồ 3 tầng. Không dùng nội dung nghiên cứu hoặc số liệu trong ảnh tham khảo. Nền trang trí tạo bằng công cụ image_gen tích hợp, prompt: nền trình chiếu trắng 16:9, điểm chấm xanh mờ và đường cong góc phải, navy/cyan, không chữ. Nội dung và sơ đồ là đối tượng PowerPoint chỉnh sửa được.</a:t>
             </a:r>
           </a:p>
         </p:txBody>
@@ -489,7 +489,7 @@
           <p:cNvPr id="3" name="Title">
             <a:extLst xmlns:a="http://schemas.openxmlformats.org/drawingml/2006/main">
               <a:ext uri="{FF2B5EF4-FFF2-40B4-BE49-F238E27FC236}">
-                <a16:creationId xmlns:a16="http://schemas.microsoft.com/office/drawing/2014/main" id="{852004DA-0308-469B-B98A-9257EC60DB08}"/>
+                <a16:creationId xmlns:a16="http://schemas.microsoft.com/office/drawing/2014/main" id="{DAE843B6-B61C-43D7-9FBD-7BAB67C74974}"/>
               </a:ext>
             </a:extLst>
           </p:cNvPr>
@@ -646,7 +646,7 @@
           <p:cNvPr id="2" name="Subtitle">
             <a:extLst xmlns:a="http://schemas.openxmlformats.org/drawingml/2006/main">
               <a:ext uri="{FF2B5EF4-FFF2-40B4-BE49-F238E27FC236}">
-                <a16:creationId xmlns:a16="http://schemas.microsoft.com/office/drawing/2014/main" id="{ADC8571C-3501-44F6-B02F-9D91ECCC27AB}"/>
+                <a16:creationId xmlns:a16="http://schemas.microsoft.com/office/drawing/2014/main" id="{61ABBC5C-17B2-4F0E-8809-25C8EFC87B1C}"/>
               </a:ext>
             </a:extLst>
           </p:cNvPr>
@@ -820,7 +820,7 @@
           <p:cNvPr id="2" name="Section title">
             <a:extLst xmlns:a="http://schemas.openxmlformats.org/drawingml/2006/main">
               <a:ext uri="{FF2B5EF4-FFF2-40B4-BE49-F238E27FC236}">
-                <a16:creationId xmlns:a16="http://schemas.microsoft.com/office/drawing/2014/main" id="{1E882421-ADF3-42D3-987B-83D63BB953D6}"/>
+                <a16:creationId xmlns:a16="http://schemas.microsoft.com/office/drawing/2014/main" id="{B0411941-385F-48AF-B515-E5454E635A28}"/>
               </a:ext>
             </a:extLst>
           </p:cNvPr>
@@ -994,7 +994,7 @@
           <p:cNvPr id="3" name="Title">
             <a:extLst xmlns:a="http://schemas.openxmlformats.org/drawingml/2006/main">
               <a:ext uri="{FF2B5EF4-FFF2-40B4-BE49-F238E27FC236}">
-                <a16:creationId xmlns:a16="http://schemas.microsoft.com/office/drawing/2014/main" id="{C4994556-205F-47A3-B96F-4FB0AC9E9775}"/>
+                <a16:creationId xmlns:a16="http://schemas.microsoft.com/office/drawing/2014/main" id="{59E3D6E2-4016-4182-970E-36BEF2EF520F}"/>
               </a:ext>
             </a:extLst>
           </p:cNvPr>
@@ -1151,7 +1151,7 @@
           <p:cNvPr id="2" name="Body">
             <a:extLst xmlns:a="http://schemas.openxmlformats.org/drawingml/2006/main">
               <a:ext uri="{FF2B5EF4-FFF2-40B4-BE49-F238E27FC236}">
-                <a16:creationId xmlns:a16="http://schemas.microsoft.com/office/drawing/2014/main" id="{D5758727-6D3B-46E9-A7A5-BB9B6B02884F}"/>
+                <a16:creationId xmlns:a16="http://schemas.microsoft.com/office/drawing/2014/main" id="{3E48E3EE-DEC6-4D5B-AE03-214E763CEFA7}"/>
               </a:ext>
             </a:extLst>
           </p:cNvPr>
@@ -1325,7 +1325,7 @@
           <p:cNvPr id="4" name="Title">
             <a:extLst xmlns:a="http://schemas.openxmlformats.org/drawingml/2006/main">
               <a:ext uri="{FF2B5EF4-FFF2-40B4-BE49-F238E27FC236}">
-                <a16:creationId xmlns:a16="http://schemas.microsoft.com/office/drawing/2014/main" id="{D61CE894-6DE6-4F3C-8EB2-4E848E247F93}"/>
+                <a16:creationId xmlns:a16="http://schemas.microsoft.com/office/drawing/2014/main" id="{07F55161-FB88-4AC4-8AD4-7BD2DAFA63C4}"/>
               </a:ext>
             </a:extLst>
           </p:cNvPr>
@@ -1482,7 +1482,7 @@
           <p:cNvPr id="2" name="Left column">
             <a:extLst xmlns:a="http://schemas.openxmlformats.org/drawingml/2006/main">
               <a:ext uri="{FF2B5EF4-FFF2-40B4-BE49-F238E27FC236}">
-                <a16:creationId xmlns:a16="http://schemas.microsoft.com/office/drawing/2014/main" id="{D7EDFC1D-5159-4A7B-A231-B22EB16596AD}"/>
+                <a16:creationId xmlns:a16="http://schemas.microsoft.com/office/drawing/2014/main" id="{5DD51E05-8FF6-4F1D-A660-28944C727617}"/>
               </a:ext>
             </a:extLst>
           </p:cNvPr>
@@ -1639,7 +1639,7 @@
           <p:cNvPr id="3" name="Right column">
             <a:extLst xmlns:a="http://schemas.openxmlformats.org/drawingml/2006/main">
               <a:ext uri="{FF2B5EF4-FFF2-40B4-BE49-F238E27FC236}">
-                <a16:creationId xmlns:a16="http://schemas.microsoft.com/office/drawing/2014/main" id="{D8ED2E52-3510-4B3F-9989-981F03DB92FC}"/>
+                <a16:creationId xmlns:a16="http://schemas.microsoft.com/office/drawing/2014/main" id="{E9C5796B-6A50-4005-99A7-75C1D2AE8042}"/>
               </a:ext>
             </a:extLst>
           </p:cNvPr>
@@ -1813,7 +1813,7 @@
           <p:cNvPr id="3" name="Title">
             <a:extLst xmlns:a="http://schemas.openxmlformats.org/drawingml/2006/main">
               <a:ext uri="{FF2B5EF4-FFF2-40B4-BE49-F238E27FC236}">
-                <a16:creationId xmlns:a16="http://schemas.microsoft.com/office/drawing/2014/main" id="{369413B9-D01E-4049-8563-F1D10BD3479E}"/>
+                <a16:creationId xmlns:a16="http://schemas.microsoft.com/office/drawing/2014/main" id="{C0EC94A6-52BD-4E03-9E58-3861793D9CA8}"/>
               </a:ext>
             </a:extLst>
           </p:cNvPr>
@@ -1970,7 +1970,7 @@
           <p:cNvPr id="2" name="Left column">
             <a:extLst xmlns:a="http://schemas.openxmlformats.org/drawingml/2006/main">
               <a:ext uri="{FF2B5EF4-FFF2-40B4-BE49-F238E27FC236}">
-                <a16:creationId xmlns:a16="http://schemas.microsoft.com/office/drawing/2014/main" id="{60031464-693B-4820-BDB0-6FF47E4FDDA3}"/>
+                <a16:creationId xmlns:a16="http://schemas.microsoft.com/office/drawing/2014/main" id="{871FBADA-28B1-41D6-A016-B18F3C03C036}"/>
               </a:ext>
             </a:extLst>
           </p:cNvPr>
@@ -2165,12 +2165,12 @@
   </p:cSld>
   <p:clrMap bg1="lt1" tx1="dk1" bg2="lt2" tx2="dk2" accent1="accent1" accent2="accent2" accent3="accent3" accent4="accent4" accent5="accent5" accent6="accent6" hlink="hlink" folHlink="folHlink"/>
   <p:sldLayoutIdLst>
-    <p:sldLayoutId xmlns:r="http://schemas.openxmlformats.org/officeDocument/2006/relationships" id="2147483649" r:id="R608474ac12f94498"/>
-    <p:sldLayoutId xmlns:r="http://schemas.openxmlformats.org/officeDocument/2006/relationships" id="2147483650" r:id="Rf3c4aaa5666549a7"/>
-    <p:sldLayoutId xmlns:r="http://schemas.openxmlformats.org/officeDocument/2006/relationships" id="2147483651" r:id="R2aa1801d3f834eeb"/>
-    <p:sldLayoutId xmlns:r="http://schemas.openxmlformats.org/officeDocument/2006/relationships" id="2147483652" r:id="Rf46f1e81c4a4435e"/>
-    <p:sldLayoutId xmlns:r="http://schemas.openxmlformats.org/officeDocument/2006/relationships" id="2147483653" r:id="Rc8db63c00ee5402b"/>
-    <p:sldLayoutId xmlns:r="http://schemas.openxmlformats.org/officeDocument/2006/relationships" id="2147483654" r:id="R7d5358c5d96c4ec7"/>
+    <p:sldLayoutId xmlns:r="http://schemas.openxmlformats.org/officeDocument/2006/relationships" id="2147483649" r:id="R4aad6d3a81a84e81"/>
+    <p:sldLayoutId xmlns:r="http://schemas.openxmlformats.org/officeDocument/2006/relationships" id="2147483650" r:id="Rdd3f011df2ec49cc"/>
+    <p:sldLayoutId xmlns:r="http://schemas.openxmlformats.org/officeDocument/2006/relationships" id="2147483651" r:id="R96093ecf2cb14b5f"/>
+    <p:sldLayoutId xmlns:r="http://schemas.openxmlformats.org/officeDocument/2006/relationships" id="2147483652" r:id="R42f4abd113e340e4"/>
+    <p:sldLayoutId xmlns:r="http://schemas.openxmlformats.org/officeDocument/2006/relationships" id="2147483653" r:id="Rebf1c90683be4a82"/>
+    <p:sldLayoutId xmlns:r="http://schemas.openxmlformats.org/officeDocument/2006/relationships" id="2147483654" r:id="R6fa477a077fb4a5c"/>
   </p:sldLayoutIdLst>
   <p:txStyles>
     <p:titleStyle>
@@ -2703,7 +2703,7 @@
     <p:bg>
       <p:bgPr>
         <a:solidFill xmlns:a="http://schemas.openxmlformats.org/drawingml/2006/main">
-          <a:srgbClr val="F8F7F3"/>
+          <a:srgbClr val="FFFFFF"/>
         </a:solidFill>
       </p:bgPr>
     </p:bg>
@@ -2716,12 +2716,40 @@
       <p:grpSpPr>
         <a:xfrm xmlns:a="http://schemas.openxmlformats.org/drawingml/2006/main"/>
       </p:grpSpPr>
-      <p:sp>
-        <p:nvSpPr>
-          <p:cNvPr id="12" name="title">
+      <p:pic>
+        <p:nvPicPr>
+          <p:cNvPr id="37" name="">
             <a:extLst xmlns:a="http://schemas.openxmlformats.org/drawingml/2006/main">
               <a:ext uri="{FF2B5EF4-FFF2-40B4-BE49-F238E27FC236}">
-                <a16:creationId xmlns:a16="http://schemas.microsoft.com/office/drawing/2014/main" id="{6E673DB6-F530-485D-9014-6A4F4C6E59BC}"/>
+                <a16:creationId xmlns:a16="http://schemas.microsoft.com/office/drawing/2014/main" id="{6EB1AF12-6923-4794-8C95-010FE4B5EB99}"/>
+              </a:ext>
+            </a:extLst>
+          </p:cNvPr>
+          <p:cNvPicPr>
+            <a:picLocks xmlns:a="http://schemas.openxmlformats.org/drawingml/2006/main" noChangeAspect="1"/>
+          </p:cNvPicPr>
+          <p:nvPr/>
+        </p:nvPicPr>
+        <p:blipFill>
+          <a:blip xmlns:r="http://schemas.openxmlformats.org/officeDocument/2006/relationships" xmlns:a="http://schemas.openxmlformats.org/drawingml/2006/main" r:embed="R4666eeba3ef34988"/>
+          <a:stretch xmlns:a="http://schemas.openxmlformats.org/drawingml/2006/main"/>
+        </p:blipFill>
+        <p:spPr>
+          <a:xfrm xmlns:a="http://schemas.openxmlformats.org/drawingml/2006/main">
+            <a:off x="0" y="0"/>
+            <a:ext cx="15240000" cy="8572500"/>
+          </a:xfrm>
+          <a:prstGeom xmlns:a="http://schemas.openxmlformats.org/drawingml/2006/main" prst="rect">
+            <a:avLst/>
+          </a:prstGeom>
+        </p:spPr>
+      </p:pic>
+      <p:sp>
+        <p:nvSpPr>
+          <p:cNvPr id="2" name="course">
+            <a:extLst xmlns:a="http://schemas.openxmlformats.org/drawingml/2006/main">
+              <a:ext uri="{FF2B5EF4-FFF2-40B4-BE49-F238E27FC236}">
+                <a16:creationId xmlns:a16="http://schemas.microsoft.com/office/drawing/2014/main" id="{7A9F45CE-B174-486D-B4D2-F13CADDB11E2}"/>
               </a:ext>
             </a:extLst>
           </p:cNvPr>
@@ -2732,8 +2760,8 @@
         </p:nvSpPr>
         <p:spPr>
           <a:xfrm xmlns:a="http://schemas.openxmlformats.org/drawingml/2006/main">
-            <a:off x="619125" y="361950"/>
-            <a:ext cx="14001750" cy="685800"/>
+            <a:off x="10953750" y="304800"/>
+            <a:ext cx="3714750" cy="266700"/>
           </a:xfrm>
           <a:prstGeom xmlns:a="http://schemas.openxmlformats.org/drawingml/2006/main" prst="rect">
             <a:avLst/>
@@ -2744,12 +2772,14 @@
           </a:ln>
         </p:spPr>
         <p:txBody>
-          <a:bodyPr xmlns:a="http://schemas.openxmlformats.org/drawingml/2006/main"/>
+          <a:bodyPr xmlns:a="http://schemas.openxmlformats.org/drawingml/2006/main" wrap="square" lIns="0" tIns="0" rIns="0" bIns="0" anchor="t">
+            <a:noAutofit/>
+          </a:bodyPr>
           <a:lstStyle xmlns:a="http://schemas.openxmlformats.org/drawingml/2006/main">
-            <a:defPPr>
-              <a:defRPr sz="3600" b="1">
-                <a:solidFill>
-                  <a:srgbClr val="162E45"/>
+            <a:defPPr algn="r">
+              <a:defRPr sz="1350" b="0">
+                <a:solidFill>
+                  <a:srgbClr val="061B60"/>
                 </a:solidFill>
                 <a:latin typeface="Arial"/>
                 <a:ea typeface="Arial"/>
@@ -2758,10 +2788,10 @@
             </a:defPPr>
           </a:lstStyle>
           <a:p xmlns:a="http://schemas.openxmlformats.org/drawingml/2006/main">
-            <a:pPr>
-              <a:defRPr sz="3600" b="1">
-                <a:solidFill>
-                  <a:srgbClr val="162E45"/>
+            <a:pPr algn="r">
+              <a:defRPr sz="1350" b="0">
+                <a:solidFill>
+                  <a:srgbClr val="061B60"/>
                 </a:solidFill>
                 <a:latin typeface="Arial"/>
                 <a:ea typeface="Arial"/>
@@ -2769,25 +2799,25 @@
               </a:defRPr>
             </a:pPr>
             <a:r>
-              <a:rPr sz="3600" b="1">
-                <a:solidFill>
-                  <a:srgbClr val="162E45"/>
+              <a:rPr sz="1350" b="0">
+                <a:solidFill>
+                  <a:srgbClr val="061B60"/>
                 </a:solidFill>
                 <a:latin typeface="Arial"/>
                 <a:ea typeface="Arial"/>
                 <a:cs typeface="Arial"/>
               </a:rPr>
-              <a:t>SổSạch: triển khai Mức 1 có kiểm soát</a:t>
+              <a:t>NEIV  /  LAB DAY 13</a:t>
             </a:r>
           </a:p>
         </p:txBody>
       </p:sp>
       <p:sp>
         <p:nvSpPr>
-          <p:cNvPr id="2" name="conclusion">
+          <p:cNvPr id="3" name="title">
             <a:extLst xmlns:a="http://schemas.openxmlformats.org/drawingml/2006/main">
               <a:ext uri="{FF2B5EF4-FFF2-40B4-BE49-F238E27FC236}">
-                <a16:creationId xmlns:a16="http://schemas.microsoft.com/office/drawing/2014/main" id="{42FD9A92-B5A7-486D-8192-1B6C69C56275}"/>
+                <a16:creationId xmlns:a16="http://schemas.microsoft.com/office/drawing/2014/main" id="{783484B9-DF05-4ED5-A78D-29F2451EC40E}"/>
               </a:ext>
             </a:extLst>
           </p:cNvPr>
@@ -2798,8 +2828,8 @@
         </p:nvSpPr>
         <p:spPr>
           <a:xfrm xmlns:a="http://schemas.openxmlformats.org/drawingml/2006/main">
-            <a:off x="619125" y="1143000"/>
-            <a:ext cx="13811250" cy="1000125"/>
+            <a:off x="590550" y="647700"/>
+            <a:ext cx="14049375" cy="609600"/>
           </a:xfrm>
           <a:prstGeom xmlns:a="http://schemas.openxmlformats.org/drawingml/2006/main" prst="rect">
             <a:avLst/>
@@ -2810,12 +2840,14 @@
           </a:ln>
         </p:spPr>
         <p:txBody>
-          <a:bodyPr xmlns:a="http://schemas.openxmlformats.org/drawingml/2006/main"/>
+          <a:bodyPr xmlns:a="http://schemas.openxmlformats.org/drawingml/2006/main" wrap="square" lIns="0" tIns="0" rIns="0" bIns="0" anchor="t">
+            <a:noAutofit/>
+          </a:bodyPr>
           <a:lstStyle xmlns:a="http://schemas.openxmlformats.org/drawingml/2006/main">
-            <a:defPPr>
-              <a:defRPr sz="2250" b="0">
-                <a:solidFill>
-                  <a:srgbClr val="162E45"/>
+            <a:defPPr algn="l">
+              <a:defRPr sz="3600" b="1">
+                <a:solidFill>
+                  <a:srgbClr val="061B60"/>
                 </a:solidFill>
                 <a:latin typeface="Arial"/>
                 <a:ea typeface="Arial"/>
@@ -2824,10 +2856,10 @@
             </a:defPPr>
           </a:lstStyle>
           <a:p xmlns:a="http://schemas.openxmlformats.org/drawingml/2006/main">
-            <a:pPr>
-              <a:defRPr sz="2250" b="0">
-                <a:solidFill>
-                  <a:srgbClr val="162E45"/>
+            <a:pPr algn="l">
+              <a:defRPr sz="3600" b="1">
+                <a:solidFill>
+                  <a:srgbClr val="061B60"/>
                 </a:solidFill>
                 <a:latin typeface="Arial"/>
                 <a:ea typeface="Arial"/>
@@ -2835,25 +2867,25 @@
               </a:defRPr>
             </a:pPr>
             <a:r>
-              <a:rPr sz="2250" b="0">
-                <a:solidFill>
-                  <a:srgbClr val="162E45"/>
+              <a:rPr sz="3600" b="1">
+                <a:solidFill>
+                  <a:srgbClr val="061B60"/>
                 </a:solidFill>
                 <a:latin typeface="Arial"/>
                 <a:ea typeface="Arial"/>
                 <a:cs typeface="Arial"/>
               </a:rPr>
-              <a:t>Đề xuất triển khai SổSạch ở Mức 1, duyệt 20% hóa đơn, mục tiêu giảm 50% giờ nhập ảnh. Chỉ lên Mức 2 khi qua cổng chất lượng, rà soát quyết định ngày 90.</a:t>
+              <a:t>SỔSẠCH: LỘ TRÌNH AI 12 THÁNG</a:t>
             </a:r>
           </a:p>
         </p:txBody>
       </p:sp>
       <p:sp>
         <p:nvSpPr>
-          <p:cNvPr id="3" name="roadmap-heading">
+          <p:cNvPr id="4" name="conclusion-border">
             <a:extLst xmlns:a="http://schemas.openxmlformats.org/drawingml/2006/main">
               <a:ext uri="{FF2B5EF4-FFF2-40B4-BE49-F238E27FC236}">
-                <a16:creationId xmlns:a16="http://schemas.microsoft.com/office/drawing/2014/main" id="{728D277D-2299-4CE0-AA68-A6638D69DA60}"/>
+                <a16:creationId xmlns:a16="http://schemas.microsoft.com/office/drawing/2014/main" id="{5DF52453-A31C-410C-A340-0E149BA83F65}"/>
               </a:ext>
             </a:extLst>
           </p:cNvPr>
@@ -2864,62 +2896,30 @@
         </p:nvSpPr>
         <p:spPr>
           <a:xfrm xmlns:a="http://schemas.openxmlformats.org/drawingml/2006/main">
-            <a:off x="619125" y="2381250"/>
-            <a:ext cx="6953250" cy="428625"/>
+            <a:off x="590550" y="1381125"/>
+            <a:ext cx="14049375" cy="1057275"/>
           </a:xfrm>
-          <a:prstGeom xmlns:a="http://schemas.openxmlformats.org/drawingml/2006/main" prst="rect">
-            <a:avLst/>
-          </a:prstGeom>
-          <a:noFill xmlns:a="http://schemas.openxmlformats.org/drawingml/2006/main"/>
-          <a:ln xmlns:a="http://schemas.openxmlformats.org/drawingml/2006/main" w="0">
-            <a:noFill/>
+          <a:prstGeom xmlns:a="http://schemas.openxmlformats.org/drawingml/2006/main" prst="roundRect">
+            <a:avLst>
+              <a:gd name="adj" fmla="val 7207"/>
+            </a:avLst>
+          </a:prstGeom>
+          <a:solidFill xmlns:a="http://schemas.openxmlformats.org/drawingml/2006/main">
+            <a:srgbClr val="F5FBFD"/>
+          </a:solidFill>
+          <a:ln xmlns:a="http://schemas.openxmlformats.org/drawingml/2006/main" w="11430">
+            <a:solidFill>
+              <a:srgbClr val="9EDBE5"/>
+            </a:solidFill>
           </a:ln>
         </p:spPr>
-        <p:txBody>
-          <a:bodyPr xmlns:a="http://schemas.openxmlformats.org/drawingml/2006/main"/>
-          <a:lstStyle xmlns:a="http://schemas.openxmlformats.org/drawingml/2006/main">
-            <a:defPPr>
-              <a:defRPr sz="2250" b="1">
-                <a:solidFill>
-                  <a:srgbClr val="162E45"/>
-                </a:solidFill>
-                <a:latin typeface="Arial"/>
-                <a:ea typeface="Arial"/>
-                <a:cs typeface="Arial"/>
-              </a:defRPr>
-            </a:defPPr>
-          </a:lstStyle>
-          <a:p xmlns:a="http://schemas.openxmlformats.org/drawingml/2006/main">
-            <a:pPr>
-              <a:defRPr sz="2250" b="1">
-                <a:solidFill>
-                  <a:srgbClr val="162E45"/>
-                </a:solidFill>
-                <a:latin typeface="Arial"/>
-                <a:ea typeface="Arial"/>
-                <a:cs typeface="Arial"/>
-              </a:defRPr>
-            </a:pPr>
-            <a:r>
-              <a:rPr sz="2250" b="1">
-                <a:solidFill>
-                  <a:srgbClr val="162E45"/>
-                </a:solidFill>
-                <a:latin typeface="Arial"/>
-                <a:ea typeface="Arial"/>
-                <a:cs typeface="Arial"/>
-              </a:rPr>
-              <a:t>3 việc chính trong 12 tháng</a:t>
-            </a:r>
-          </a:p>
-        </p:txBody>
-      </p:sp>
-      <p:sp>
-        <p:nvSpPr>
-          <p:cNvPr id="4" name="roadmap">
+      </p:sp>
+      <p:sp>
+        <p:nvSpPr>
+          <p:cNvPr id="5" name="conclusion-circle">
             <a:extLst xmlns:a="http://schemas.openxmlformats.org/drawingml/2006/main">
               <a:ext uri="{FF2B5EF4-FFF2-40B4-BE49-F238E27FC236}">
-                <a16:creationId xmlns:a16="http://schemas.microsoft.com/office/drawing/2014/main" id="{6D212E97-7926-40DC-9BB2-8815E2D77244}"/>
+                <a16:creationId xmlns:a16="http://schemas.microsoft.com/office/drawing/2014/main" id="{2B079B90-DBA3-48CC-8F48-38E6FB4D59BA}"/>
               </a:ext>
             </a:extLst>
           </p:cNvPr>
@@ -2930,62 +2930,26 @@
         </p:nvSpPr>
         <p:spPr>
           <a:xfrm xmlns:a="http://schemas.openxmlformats.org/drawingml/2006/main">
-            <a:off x="619125" y="2914650"/>
-            <a:ext cx="6667500" cy="1685925"/>
+            <a:off x="762000" y="1600200"/>
+            <a:ext cx="495300" cy="495300"/>
           </a:xfrm>
-          <a:prstGeom xmlns:a="http://schemas.openxmlformats.org/drawingml/2006/main" prst="rect">
+          <a:prstGeom xmlns:a="http://schemas.openxmlformats.org/drawingml/2006/main" prst="ellipse">
             <a:avLst/>
           </a:prstGeom>
-          <a:noFill xmlns:a="http://schemas.openxmlformats.org/drawingml/2006/main"/>
+          <a:solidFill xmlns:a="http://schemas.openxmlformats.org/drawingml/2006/main">
+            <a:srgbClr val="061B60"/>
+          </a:solidFill>
           <a:ln xmlns:a="http://schemas.openxmlformats.org/drawingml/2006/main" w="0">
             <a:noFill/>
           </a:ln>
         </p:spPr>
-        <p:txBody>
-          <a:bodyPr xmlns:a="http://schemas.openxmlformats.org/drawingml/2006/main"/>
-          <a:lstStyle xmlns:a="http://schemas.openxmlformats.org/drawingml/2006/main">
-            <a:defPPr>
-              <a:defRPr sz="2100" b="0">
-                <a:solidFill>
-                  <a:srgbClr val="162E45"/>
-                </a:solidFill>
-                <a:latin typeface="Arial"/>
-                <a:ea typeface="Arial"/>
-                <a:cs typeface="Arial"/>
-              </a:defRPr>
-            </a:defPPr>
-          </a:lstStyle>
-          <a:p xmlns:a="http://schemas.openxmlformats.org/drawingml/2006/main">
-            <a:pPr>
-              <a:defRPr sz="2100" b="0">
-                <a:solidFill>
-                  <a:srgbClr val="162E45"/>
-                </a:solidFill>
-                <a:latin typeface="Arial"/>
-                <a:ea typeface="Arial"/>
-                <a:cs typeface="Arial"/>
-              </a:defRPr>
-            </a:pPr>
-            <a:r>
-              <a:rPr sz="2100" b="0">
-                <a:solidFill>
-                  <a:srgbClr val="162E45"/>
-                </a:solidFill>
-                <a:latin typeface="Arial"/>
-                <a:ea typeface="Arial"/>
-                <a:cs typeface="Arial"/>
-              </a:rPr>
-              <a:t>0–3 tháng: đọc ảnh và gắn cờ. 3–6 tháng: đối chiếu mã số thuế, tích hợp dịch vụ sẵn có. 6–12 tháng: mở rộng có điều kiện, khám phá hạch toán khi đủ dữ liệu.</a:t>
-            </a:r>
-          </a:p>
-        </p:txBody>
-      </p:sp>
-      <p:sp>
-        <p:nvSpPr>
-          <p:cNvPr id="5" name="resources-heading">
+      </p:sp>
+      <p:sp>
+        <p:nvSpPr>
+          <p:cNvPr id="6" name="conclusion-number">
             <a:extLst xmlns:a="http://schemas.openxmlformats.org/drawingml/2006/main">
               <a:ext uri="{FF2B5EF4-FFF2-40B4-BE49-F238E27FC236}">
-                <a16:creationId xmlns:a16="http://schemas.microsoft.com/office/drawing/2014/main" id="{42020F8D-A88B-4B2F-AEBE-2C59CEAA3FE1}"/>
+                <a16:creationId xmlns:a16="http://schemas.microsoft.com/office/drawing/2014/main" id="{2A124610-8E25-4DDF-ACD7-FEE65932D83B}"/>
               </a:ext>
             </a:extLst>
           </p:cNvPr>
@@ -2996,8 +2960,8 @@
         </p:nvSpPr>
         <p:spPr>
           <a:xfrm xmlns:a="http://schemas.openxmlformats.org/drawingml/2006/main">
-            <a:off x="8048625" y="2381250"/>
-            <a:ext cx="6381750" cy="428625"/>
+            <a:off x="762000" y="1714500"/>
+            <a:ext cx="495300" cy="285750"/>
           </a:xfrm>
           <a:prstGeom xmlns:a="http://schemas.openxmlformats.org/drawingml/2006/main" prst="rect">
             <a:avLst/>
@@ -3008,12 +2972,14 @@
           </a:ln>
         </p:spPr>
         <p:txBody>
-          <a:bodyPr xmlns:a="http://schemas.openxmlformats.org/drawingml/2006/main"/>
+          <a:bodyPr xmlns:a="http://schemas.openxmlformats.org/drawingml/2006/main" wrap="square" lIns="0" tIns="0" rIns="0" bIns="0" anchor="t">
+            <a:noAutofit/>
+          </a:bodyPr>
           <a:lstStyle xmlns:a="http://schemas.openxmlformats.org/drawingml/2006/main">
-            <a:defPPr>
-              <a:defRPr sz="2250" b="1">
-                <a:solidFill>
-                  <a:srgbClr val="162E45"/>
+            <a:defPPr algn="ctr">
+              <a:defRPr sz="1725" b="1">
+                <a:solidFill>
+                  <a:srgbClr val="FFFFFF"/>
                 </a:solidFill>
                 <a:latin typeface="Arial"/>
                 <a:ea typeface="Arial"/>
@@ -3022,10 +2988,10 @@
             </a:defPPr>
           </a:lstStyle>
           <a:p xmlns:a="http://schemas.openxmlformats.org/drawingml/2006/main">
-            <a:pPr>
-              <a:defRPr sz="2250" b="1">
-                <a:solidFill>
-                  <a:srgbClr val="162E45"/>
+            <a:pPr algn="ctr">
+              <a:defRPr sz="1725" b="1">
+                <a:solidFill>
+                  <a:srgbClr val="FFFFFF"/>
                 </a:solidFill>
                 <a:latin typeface="Arial"/>
                 <a:ea typeface="Arial"/>
@@ -3033,25 +2999,25 @@
               </a:defRPr>
             </a:pPr>
             <a:r>
-              <a:rPr sz="2250" b="1">
-                <a:solidFill>
-                  <a:srgbClr val="162E45"/>
+              <a:rPr sz="1725" b="1">
+                <a:solidFill>
+                  <a:srgbClr val="FFFFFF"/>
                 </a:solidFill>
                 <a:latin typeface="Arial"/>
                 <a:ea typeface="Arial"/>
                 <a:cs typeface="Arial"/>
               </a:rPr>
-              <a:t>Cần gì</a:t>
+              <a:t>01</a:t>
             </a:r>
           </a:p>
         </p:txBody>
       </p:sp>
       <p:sp>
         <p:nvSpPr>
-          <p:cNvPr id="6" name="resources">
+          <p:cNvPr id="7" name="conclusion-label">
             <a:extLst xmlns:a="http://schemas.openxmlformats.org/drawingml/2006/main">
               <a:ext uri="{FF2B5EF4-FFF2-40B4-BE49-F238E27FC236}">
-                <a16:creationId xmlns:a16="http://schemas.microsoft.com/office/drawing/2014/main" id="{8C836D28-44B8-48B6-B1FD-B1E7A10DDC61}"/>
+                <a16:creationId xmlns:a16="http://schemas.microsoft.com/office/drawing/2014/main" id="{3E574076-DE17-4798-B4A5-546F800920C9}"/>
               </a:ext>
             </a:extLst>
           </p:cNvPr>
@@ -3062,8 +3028,8 @@
         </p:nvSpPr>
         <p:spPr>
           <a:xfrm xmlns:a="http://schemas.openxmlformats.org/drawingml/2006/main">
-            <a:off x="8048625" y="2914650"/>
-            <a:ext cx="6477000" cy="1952625"/>
+            <a:off x="1428750" y="1476375"/>
+            <a:ext cx="2571750" cy="285750"/>
           </a:xfrm>
           <a:prstGeom xmlns:a="http://schemas.openxmlformats.org/drawingml/2006/main" prst="rect">
             <a:avLst/>
@@ -3074,12 +3040,14 @@
           </a:ln>
         </p:spPr>
         <p:txBody>
-          <a:bodyPr xmlns:a="http://schemas.openxmlformats.org/drawingml/2006/main"/>
+          <a:bodyPr xmlns:a="http://schemas.openxmlformats.org/drawingml/2006/main" wrap="square" lIns="0" tIns="0" rIns="0" bIns="0" anchor="t">
+            <a:noAutofit/>
+          </a:bodyPr>
           <a:lstStyle xmlns:a="http://schemas.openxmlformats.org/drawingml/2006/main">
-            <a:defPPr>
-              <a:defRPr sz="1950" b="0">
-                <a:solidFill>
-                  <a:srgbClr val="162E45"/>
+            <a:defPPr algn="l">
+              <a:defRPr sz="1725" b="1">
+                <a:solidFill>
+                  <a:srgbClr val="009FB8"/>
                 </a:solidFill>
                 <a:latin typeface="Arial"/>
                 <a:ea typeface="Arial"/>
@@ -3088,10 +3056,10 @@
             </a:defPPr>
           </a:lstStyle>
           <a:p xmlns:a="http://schemas.openxmlformats.org/drawingml/2006/main">
-            <a:pPr>
-              <a:defRPr sz="1950" b="0">
-                <a:solidFill>
-                  <a:srgbClr val="162E45"/>
+            <a:pPr algn="l">
+              <a:defRPr sz="1725" b="1">
+                <a:solidFill>
+                  <a:srgbClr val="009FB8"/>
                 </a:solidFill>
                 <a:latin typeface="Arial"/>
                 <a:ea typeface="Arial"/>
@@ -3099,25 +3067,25 @@
               </a:defRPr>
             </a:pPr>
             <a:r>
-              <a:rPr sz="1950" b="0">
-                <a:solidFill>
-                  <a:srgbClr val="162E45"/>
+              <a:rPr sz="1725" b="1">
+                <a:solidFill>
+                  <a:srgbClr val="009FB8"/>
                 </a:solidFill>
                 <a:latin typeface="Arial"/>
                 <a:ea typeface="Arial"/>
                 <a:cs typeface="Arial"/>
               </a:rPr>
-              <a:t>Cần bộ đề 40 hóa đơn, quyền dùng dữ liệu và kết nối phần mềm. Chị Hạnh tối đa 3 giờ/tuần, anh Tùng hỗ trợ chấm. Công ty bố trí 60 giờ duyệt/tháng cho 12.000 hóa đơn. Mức 1: 704 đồng/việc, biên gộp 68,79% theo giả định đề.</a:t>
+              <a:t>KẾT LUẬN</a:t>
             </a:r>
           </a:p>
         </p:txBody>
       </p:sp>
       <p:sp>
         <p:nvSpPr>
-          <p:cNvPr id="7" name="risk-heading">
+          <p:cNvPr id="8" name="conclusion">
             <a:extLst xmlns:a="http://schemas.openxmlformats.org/drawingml/2006/main">
               <a:ext uri="{FF2B5EF4-FFF2-40B4-BE49-F238E27FC236}">
-                <a16:creationId xmlns:a16="http://schemas.microsoft.com/office/drawing/2014/main" id="{5840B414-800A-4648-85F0-CD95F29D73DC}"/>
+                <a16:creationId xmlns:a16="http://schemas.microsoft.com/office/drawing/2014/main" id="{DE99BE04-1B32-4B93-9AD3-734797C66C45}"/>
               </a:ext>
             </a:extLst>
           </p:cNvPr>
@@ -3128,8 +3096,8 @@
         </p:nvSpPr>
         <p:spPr>
           <a:xfrm xmlns:a="http://schemas.openxmlformats.org/drawingml/2006/main">
-            <a:off x="619125" y="5095875"/>
-            <a:ext cx="6953250" cy="428625"/>
+            <a:off x="1428750" y="1819275"/>
+            <a:ext cx="12954000" cy="561975"/>
           </a:xfrm>
           <a:prstGeom xmlns:a="http://schemas.openxmlformats.org/drawingml/2006/main" prst="rect">
             <a:avLst/>
@@ -3140,12 +3108,14 @@
           </a:ln>
         </p:spPr>
         <p:txBody>
-          <a:bodyPr xmlns:a="http://schemas.openxmlformats.org/drawingml/2006/main"/>
+          <a:bodyPr xmlns:a="http://schemas.openxmlformats.org/drawingml/2006/main" wrap="square" lIns="0" tIns="0" rIns="0" bIns="0" anchor="t">
+            <a:noAutofit/>
+          </a:bodyPr>
           <a:lstStyle xmlns:a="http://schemas.openxmlformats.org/drawingml/2006/main">
-            <a:defPPr>
-              <a:defRPr sz="2250" b="1">
-                <a:solidFill>
-                  <a:srgbClr val="162E45"/>
+            <a:defPPr algn="l">
+              <a:defRPr sz="1950" b="0">
+                <a:solidFill>
+                  <a:srgbClr val="061B60"/>
                 </a:solidFill>
                 <a:latin typeface="Arial"/>
                 <a:ea typeface="Arial"/>
@@ -3154,10 +3124,10 @@
             </a:defPPr>
           </a:lstStyle>
           <a:p xmlns:a="http://schemas.openxmlformats.org/drawingml/2006/main">
-            <a:pPr>
-              <a:defRPr sz="2250" b="1">
-                <a:solidFill>
-                  <a:srgbClr val="162E45"/>
+            <a:pPr algn="l">
+              <a:defRPr sz="1950" b="0">
+                <a:solidFill>
+                  <a:srgbClr val="061B60"/>
                 </a:solidFill>
                 <a:latin typeface="Arial"/>
                 <a:ea typeface="Arial"/>
@@ -3165,25 +3135,25 @@
               </a:defRPr>
             </a:pPr>
             <a:r>
-              <a:rPr sz="2250" b="1">
-                <a:solidFill>
-                  <a:srgbClr val="162E45"/>
+              <a:rPr sz="1950" b="0">
+                <a:solidFill>
+                  <a:srgbClr val="061B60"/>
                 </a:solidFill>
                 <a:latin typeface="Arial"/>
                 <a:ea typeface="Arial"/>
                 <a:cs typeface="Arial"/>
               </a:rPr>
-              <a:t>Rủi ro lớn nhất và cách xử lý</a:t>
+              <a:t>Đề xuất triển khai SổSạch ở Mức 1, duyệt 20% hóa đơn, mục tiêu giảm 50% giờ nhập ảnh. Chỉ lên Mức 2 khi qua cổng chất lượng, rà soát quyết định ngày 90.</a:t>
             </a:r>
           </a:p>
         </p:txBody>
       </p:sp>
       <p:sp>
         <p:nvSpPr>
-          <p:cNvPr id="8" name="risk">
+          <p:cNvPr id="9" name="panel-03">
             <a:extLst xmlns:a="http://schemas.openxmlformats.org/drawingml/2006/main">
               <a:ext uri="{FF2B5EF4-FFF2-40B4-BE49-F238E27FC236}">
-                <a16:creationId xmlns:a16="http://schemas.microsoft.com/office/drawing/2014/main" id="{13F3A9DE-F045-417D-BDE7-EB6DD47D76F5}"/>
+                <a16:creationId xmlns:a16="http://schemas.microsoft.com/office/drawing/2014/main" id="{CC3BD93B-20E3-416D-AF66-529810BF3D42}"/>
               </a:ext>
             </a:extLst>
           </p:cNvPr>
@@ -3194,62 +3164,30 @@
         </p:nvSpPr>
         <p:spPr>
           <a:xfrm xmlns:a="http://schemas.openxmlformats.org/drawingml/2006/main">
-            <a:off x="619125" y="5629275"/>
-            <a:ext cx="6667500" cy="2000250"/>
+            <a:off x="590550" y="2724150"/>
+            <a:ext cx="9001125" cy="1514475"/>
           </a:xfrm>
-          <a:prstGeom xmlns:a="http://schemas.openxmlformats.org/drawingml/2006/main" prst="rect">
-            <a:avLst/>
-          </a:prstGeom>
-          <a:noFill xmlns:a="http://schemas.openxmlformats.org/drawingml/2006/main"/>
-          <a:ln xmlns:a="http://schemas.openxmlformats.org/drawingml/2006/main" w="0">
-            <a:noFill/>
+          <a:prstGeom xmlns:a="http://schemas.openxmlformats.org/drawingml/2006/main" prst="roundRect">
+            <a:avLst>
+              <a:gd name="adj" fmla="val 5031"/>
+            </a:avLst>
+          </a:prstGeom>
+          <a:solidFill xmlns:a="http://schemas.openxmlformats.org/drawingml/2006/main">
+            <a:srgbClr val="FFFFFF"/>
+          </a:solidFill>
+          <a:ln xmlns:a="http://schemas.openxmlformats.org/drawingml/2006/main" w="11906">
+            <a:solidFill>
+              <a:srgbClr val="8090B7"/>
+            </a:solidFill>
           </a:ln>
         </p:spPr>
-        <p:txBody>
-          <a:bodyPr xmlns:a="http://schemas.openxmlformats.org/drawingml/2006/main"/>
-          <a:lstStyle xmlns:a="http://schemas.openxmlformats.org/drawingml/2006/main">
-            <a:defPPr>
-              <a:defRPr sz="1950" b="0">
-                <a:solidFill>
-                  <a:srgbClr val="162E45"/>
-                </a:solidFill>
-                <a:latin typeface="Arial"/>
-                <a:ea typeface="Arial"/>
-                <a:cs typeface="Arial"/>
-              </a:defRPr>
-            </a:defPPr>
-          </a:lstStyle>
-          <a:p xmlns:a="http://schemas.openxmlformats.org/drawingml/2006/main">
-            <a:pPr>
-              <a:defRPr sz="1950" b="0">
-                <a:solidFill>
-                  <a:srgbClr val="162E45"/>
-                </a:solidFill>
-                <a:latin typeface="Arial"/>
-                <a:ea typeface="Arial"/>
-                <a:cs typeface="Arial"/>
-              </a:defRPr>
-            </a:pPr>
-            <a:r>
-              <a:rPr sz="1950" b="0">
-                <a:solidFill>
-                  <a:srgbClr val="162E45"/>
-                </a:solidFill>
-                <a:latin typeface="Arial"/>
-                <a:ea typeface="Arial"/>
-                <a:cs typeface="Arial"/>
-              </a:rPr>
-              <a:t>Sai mã số thuế hoặc tiền: ngừng tự nhập ngay. Duyệt mọi cờ và lấy mẫu. Nếu doanh thu dưới 3,71 triệu/văn phòng trong 2 tháng, với ít nhất 10 văn phòng, dừng mở rộng. Chưa đủ mẫu thì giữ thử nghiệm, lưu ý kịch bản hết tiền tháng 7.</a:t>
-            </a:r>
-          </a:p>
-        </p:txBody>
-      </p:sp>
-      <p:sp>
-        <p:nvSpPr>
-          <p:cNvPr id="9" name="review-heading">
+      </p:sp>
+      <p:sp>
+        <p:nvSpPr>
+          <p:cNvPr id="10" name="number-circle-03">
             <a:extLst xmlns:a="http://schemas.openxmlformats.org/drawingml/2006/main">
               <a:ext uri="{FF2B5EF4-FFF2-40B4-BE49-F238E27FC236}">
-                <a16:creationId xmlns:a16="http://schemas.microsoft.com/office/drawing/2014/main" id="{8A529200-E5C8-4C69-B1DF-6699230C9E34}"/>
+                <a16:creationId xmlns:a16="http://schemas.microsoft.com/office/drawing/2014/main" id="{900F2D25-9A51-480F-A726-2EBDAAB85EE1}"/>
               </a:ext>
             </a:extLst>
           </p:cNvPr>
@@ -3260,62 +3198,26 @@
         </p:nvSpPr>
         <p:spPr>
           <a:xfrm xmlns:a="http://schemas.openxmlformats.org/drawingml/2006/main">
-            <a:off x="8048625" y="5095875"/>
-            <a:ext cx="6381750" cy="428625"/>
+            <a:off x="742950" y="2867025"/>
+            <a:ext cx="466725" cy="466725"/>
           </a:xfrm>
-          <a:prstGeom xmlns:a="http://schemas.openxmlformats.org/drawingml/2006/main" prst="rect">
+          <a:prstGeom xmlns:a="http://schemas.openxmlformats.org/drawingml/2006/main" prst="ellipse">
             <a:avLst/>
           </a:prstGeom>
-          <a:noFill xmlns:a="http://schemas.openxmlformats.org/drawingml/2006/main"/>
+          <a:solidFill xmlns:a="http://schemas.openxmlformats.org/drawingml/2006/main">
+            <a:srgbClr val="061B60"/>
+          </a:solidFill>
           <a:ln xmlns:a="http://schemas.openxmlformats.org/drawingml/2006/main" w="0">
             <a:noFill/>
           </a:ln>
         </p:spPr>
-        <p:txBody>
-          <a:bodyPr xmlns:a="http://schemas.openxmlformats.org/drawingml/2006/main"/>
-          <a:lstStyle xmlns:a="http://schemas.openxmlformats.org/drawingml/2006/main">
-            <a:defPPr>
-              <a:defRPr sz="2250" b="1">
-                <a:solidFill>
-                  <a:srgbClr val="162E45"/>
-                </a:solidFill>
-                <a:latin typeface="Arial"/>
-                <a:ea typeface="Arial"/>
-                <a:cs typeface="Arial"/>
-              </a:defRPr>
-            </a:defPPr>
-          </a:lstStyle>
-          <a:p xmlns:a="http://schemas.openxmlformats.org/drawingml/2006/main">
-            <a:pPr>
-              <a:defRPr sz="2250" b="1">
-                <a:solidFill>
-                  <a:srgbClr val="162E45"/>
-                </a:solidFill>
-                <a:latin typeface="Arial"/>
-                <a:ea typeface="Arial"/>
-                <a:cs typeface="Arial"/>
-              </a:defRPr>
-            </a:pPr>
-            <a:r>
-              <a:rPr sz="2250" b="1">
-                <a:solidFill>
-                  <a:srgbClr val="162E45"/>
-                </a:solidFill>
-                <a:latin typeface="Arial"/>
-                <a:ea typeface="Arial"/>
-                <a:cs typeface="Arial"/>
-              </a:rPr>
-              <a:t>Khi nào xem lại</a:t>
-            </a:r>
-          </a:p>
-        </p:txBody>
-      </p:sp>
-      <p:sp>
-        <p:nvSpPr>
-          <p:cNvPr id="10" name="review">
+      </p:sp>
+      <p:sp>
+        <p:nvSpPr>
+          <p:cNvPr id="11" name="number-03">
             <a:extLst xmlns:a="http://schemas.openxmlformats.org/drawingml/2006/main">
               <a:ext uri="{FF2B5EF4-FFF2-40B4-BE49-F238E27FC236}">
-                <a16:creationId xmlns:a16="http://schemas.microsoft.com/office/drawing/2014/main" id="{02CE159F-DD4D-46CB-B7B5-24207A6C6368}"/>
+                <a16:creationId xmlns:a16="http://schemas.microsoft.com/office/drawing/2014/main" id="{FDE42700-8031-4656-9B43-2BD0974F185B}"/>
               </a:ext>
             </a:extLst>
           </p:cNvPr>
@@ -3326,8 +3228,8 @@
         </p:nvSpPr>
         <p:spPr>
           <a:xfrm xmlns:a="http://schemas.openxmlformats.org/drawingml/2006/main">
-            <a:off x="8048625" y="5629275"/>
-            <a:ext cx="6477000" cy="2000250"/>
+            <a:off x="742950" y="2971800"/>
+            <a:ext cx="466725" cy="285750"/>
           </a:xfrm>
           <a:prstGeom xmlns:a="http://schemas.openxmlformats.org/drawingml/2006/main" prst="rect">
             <a:avLst/>
@@ -3338,12 +3240,14 @@
           </a:ln>
         </p:spPr>
         <p:txBody>
-          <a:bodyPr xmlns:a="http://schemas.openxmlformats.org/drawingml/2006/main"/>
+          <a:bodyPr xmlns:a="http://schemas.openxmlformats.org/drawingml/2006/main" wrap="square" lIns="0" tIns="0" rIns="0" bIns="0" anchor="t">
+            <a:noAutofit/>
+          </a:bodyPr>
           <a:lstStyle xmlns:a="http://schemas.openxmlformats.org/drawingml/2006/main">
-            <a:defPPr>
-              <a:defRPr sz="1950" b="0">
-                <a:solidFill>
-                  <a:srgbClr val="162E45"/>
+            <a:defPPr algn="ctr">
+              <a:defRPr sz="1650" b="1">
+                <a:solidFill>
+                  <a:srgbClr val="FFFFFF"/>
                 </a:solidFill>
                 <a:latin typeface="Arial"/>
                 <a:ea typeface="Arial"/>
@@ -3352,10 +3256,10 @@
             </a:defPPr>
           </a:lstStyle>
           <a:p xmlns:a="http://schemas.openxmlformats.org/drawingml/2006/main">
-            <a:pPr>
-              <a:defRPr sz="1950" b="0">
-                <a:solidFill>
-                  <a:srgbClr val="162E45"/>
+            <a:pPr algn="ctr">
+              <a:defRPr sz="1650" b="1">
+                <a:solidFill>
+                  <a:srgbClr val="FFFFFF"/>
                 </a:solidFill>
                 <a:latin typeface="Arial"/>
                 <a:ea typeface="Arial"/>
@@ -3363,25 +3267,25 @@
               </a:defRPr>
             </a:pPr>
             <a:r>
-              <a:rPr sz="1950" b="0">
-                <a:solidFill>
-                  <a:srgbClr val="162E45"/>
+              <a:rPr sz="1650" b="1">
+                <a:solidFill>
+                  <a:srgbClr val="FFFFFF"/>
                 </a:solidFill>
                 <a:latin typeface="Arial"/>
                 <a:ea typeface="Arial"/>
                 <a:cs typeface="Arial"/>
               </a:rPr>
-              <a:t>Ngày 30/60/90 từ lúc bắt đầu: xem lỗi, cờ thừa, giờ nhập và chi phí. Mức 2 cần 0 lỗi nghiêm trọng/300 hóa đơn kiểm tra, đạt từ 95%, không tầng tụt. Mô hình, giá hoặc quy định đổi: rà soát ngay. Các ngưỡng mới là đề xuất cần kiểm chứng.</a:t>
+              <a:t>03</a:t>
             </a:r>
           </a:p>
         </p:txBody>
       </p:sp>
       <p:sp>
         <p:nvSpPr>
-          <p:cNvPr id="11" name="identity">
+          <p:cNvPr id="12" name="heading-03">
             <a:extLst xmlns:a="http://schemas.openxmlformats.org/drawingml/2006/main">
               <a:ext uri="{FF2B5EF4-FFF2-40B4-BE49-F238E27FC236}">
-                <a16:creationId xmlns:a16="http://schemas.microsoft.com/office/drawing/2014/main" id="{C11900D9-573F-4174-9FC6-C49B8DE3008D}"/>
+                <a16:creationId xmlns:a16="http://schemas.microsoft.com/office/drawing/2014/main" id="{6207A1F3-3D88-4C0F-8738-45BE6017D066}"/>
               </a:ext>
             </a:extLst>
           </p:cNvPr>
@@ -3392,8 +3296,8 @@
         </p:nvSpPr>
         <p:spPr>
           <a:xfrm xmlns:a="http://schemas.openxmlformats.org/drawingml/2006/main">
-            <a:off x="619125" y="8020050"/>
-            <a:ext cx="14001750" cy="285750"/>
+            <a:off x="1381125" y="2847975"/>
+            <a:ext cx="7715250" cy="304800"/>
           </a:xfrm>
           <a:prstGeom xmlns:a="http://schemas.openxmlformats.org/drawingml/2006/main" prst="rect">
             <a:avLst/>
@@ -3404,12 +3308,14 @@
           </a:ln>
         </p:spPr>
         <p:txBody>
-          <a:bodyPr xmlns:a="http://schemas.openxmlformats.org/drawingml/2006/main"/>
+          <a:bodyPr xmlns:a="http://schemas.openxmlformats.org/drawingml/2006/main" wrap="square" lIns="0" tIns="0" rIns="0" bIns="0" anchor="t">
+            <a:noAutofit/>
+          </a:bodyPr>
           <a:lstStyle xmlns:a="http://schemas.openxmlformats.org/drawingml/2006/main">
-            <a:defPPr>
-              <a:defRPr sz="1425" b="0">
-                <a:solidFill>
-                  <a:srgbClr val="566371"/>
+            <a:defPPr algn="l">
+              <a:defRPr sz="1800" b="1">
+                <a:solidFill>
+                  <a:srgbClr val="061B60"/>
                 </a:solidFill>
                 <a:latin typeface="Arial"/>
                 <a:ea typeface="Arial"/>
@@ -3418,10 +3324,10 @@
             </a:defPPr>
           </a:lstStyle>
           <a:p xmlns:a="http://schemas.openxmlformats.org/drawingml/2006/main">
-            <a:pPr>
-              <a:defRPr sz="1425" b="0">
-                <a:solidFill>
-                  <a:srgbClr val="566371"/>
+            <a:pPr algn="l">
+              <a:defRPr sz="1800" b="1">
+                <a:solidFill>
+                  <a:srgbClr val="061B60"/>
                 </a:solidFill>
                 <a:latin typeface="Arial"/>
                 <a:ea typeface="Arial"/>
@@ -3429,23 +3335,1327 @@
               </a:defRPr>
             </a:pPr>
             <a:r>
-              <a:rPr sz="1425" b="0">
-                <a:solidFill>
-                  <a:srgbClr val="566371"/>
+              <a:rPr sz="1800" b="1">
+                <a:solidFill>
+                  <a:srgbClr val="061B60"/>
                 </a:solidFill>
                 <a:latin typeface="Arial"/>
                 <a:ea typeface="Arial"/>
                 <a:cs typeface="Arial"/>
               </a:rPr>
-              <a:t>Neiv · Dương Thị Hồng Viên · 2A202602385 · VinUni AI Thực Chiến – Cohort IV · Lab Day 13</a:t>
+              <a:t>CẦN GÌ</a:t>
             </a:r>
           </a:p>
         </p:txBody>
       </p:sp>
+      <p:sp>
+        <p:nvSpPr>
+          <p:cNvPr id="13" name="body-03">
+            <a:extLst xmlns:a="http://schemas.openxmlformats.org/drawingml/2006/main">
+              <a:ext uri="{FF2B5EF4-FFF2-40B4-BE49-F238E27FC236}">
+                <a16:creationId xmlns:a16="http://schemas.microsoft.com/office/drawing/2014/main" id="{669B76AA-D97A-44B6-B14B-E388583060C3}"/>
+              </a:ext>
+            </a:extLst>
+          </p:cNvPr>
+          <p:cNvSpPr>
+            <a:spLocks xmlns:a="http://schemas.openxmlformats.org/drawingml/2006/main" noGrp="1"/>
+          </p:cNvSpPr>
+          <p:nvPr/>
+        </p:nvSpPr>
+        <p:spPr>
+          <a:xfrm xmlns:a="http://schemas.openxmlformats.org/drawingml/2006/main">
+            <a:off x="1381125" y="3219450"/>
+            <a:ext cx="7981950" cy="942975"/>
+          </a:xfrm>
+          <a:prstGeom xmlns:a="http://schemas.openxmlformats.org/drawingml/2006/main" prst="rect">
+            <a:avLst/>
+          </a:prstGeom>
+          <a:noFill xmlns:a="http://schemas.openxmlformats.org/drawingml/2006/main"/>
+          <a:ln xmlns:a="http://schemas.openxmlformats.org/drawingml/2006/main" w="0">
+            <a:noFill/>
+          </a:ln>
+        </p:spPr>
+        <p:txBody>
+          <a:bodyPr xmlns:a="http://schemas.openxmlformats.org/drawingml/2006/main" wrap="square" lIns="0" tIns="0" rIns="0" bIns="0" anchor="t">
+            <a:noAutofit/>
+          </a:bodyPr>
+          <a:lstStyle xmlns:a="http://schemas.openxmlformats.org/drawingml/2006/main">
+            <a:defPPr algn="l">
+              <a:defRPr sz="1725" b="0">
+                <a:solidFill>
+                  <a:srgbClr val="061B60"/>
+                </a:solidFill>
+                <a:latin typeface="Arial"/>
+                <a:ea typeface="Arial"/>
+                <a:cs typeface="Arial"/>
+              </a:defRPr>
+            </a:defPPr>
+          </a:lstStyle>
+          <a:p xmlns:a="http://schemas.openxmlformats.org/drawingml/2006/main">
+            <a:pPr algn="l">
+              <a:defRPr sz="1725" b="0">
+                <a:solidFill>
+                  <a:srgbClr val="061B60"/>
+                </a:solidFill>
+                <a:latin typeface="Arial"/>
+                <a:ea typeface="Arial"/>
+                <a:cs typeface="Arial"/>
+              </a:defRPr>
+            </a:pPr>
+            <a:r>
+              <a:rPr sz="1725" b="0">
+                <a:solidFill>
+                  <a:srgbClr val="061B60"/>
+                </a:solidFill>
+                <a:latin typeface="Arial"/>
+                <a:ea typeface="Arial"/>
+                <a:cs typeface="Arial"/>
+              </a:rPr>
+              <a:t>Cần bộ đề 40 hóa đơn, quyền dùng dữ liệu và kết nối phần mềm. Chị Hạnh tối đa 3 giờ/tuần, anh Tùng hỗ trợ chấm. Công ty bố trí 60 giờ duyệt/tháng cho 12.000 hóa đơn. Mức 1: 704 đồng/việc, biên gộp 68,79% theo giả định đề.</a:t>
+            </a:r>
+          </a:p>
+        </p:txBody>
+      </p:sp>
+      <p:sp>
+        <p:nvSpPr>
+          <p:cNvPr id="14" name="panel-04">
+            <a:extLst xmlns:a="http://schemas.openxmlformats.org/drawingml/2006/main">
+              <a:ext uri="{FF2B5EF4-FFF2-40B4-BE49-F238E27FC236}">
+                <a16:creationId xmlns:a16="http://schemas.microsoft.com/office/drawing/2014/main" id="{F8F699BD-3188-4177-A276-7172DB142E0D}"/>
+              </a:ext>
+            </a:extLst>
+          </p:cNvPr>
+          <p:cNvSpPr>
+            <a:spLocks xmlns:a="http://schemas.openxmlformats.org/drawingml/2006/main" noGrp="1"/>
+          </p:cNvSpPr>
+          <p:nvPr/>
+        </p:nvSpPr>
+        <p:spPr>
+          <a:xfrm xmlns:a="http://schemas.openxmlformats.org/drawingml/2006/main">
+            <a:off x="590550" y="4391025"/>
+            <a:ext cx="9001125" cy="1552575"/>
+          </a:xfrm>
+          <a:prstGeom xmlns:a="http://schemas.openxmlformats.org/drawingml/2006/main" prst="roundRect">
+            <a:avLst>
+              <a:gd name="adj" fmla="val 4908"/>
+            </a:avLst>
+          </a:prstGeom>
+          <a:solidFill xmlns:a="http://schemas.openxmlformats.org/drawingml/2006/main">
+            <a:srgbClr val="FFFFFF"/>
+          </a:solidFill>
+          <a:ln xmlns:a="http://schemas.openxmlformats.org/drawingml/2006/main" w="11906">
+            <a:solidFill>
+              <a:srgbClr val="8090B7"/>
+            </a:solidFill>
+          </a:ln>
+        </p:spPr>
+      </p:sp>
+      <p:sp>
+        <p:nvSpPr>
+          <p:cNvPr id="15" name="number-circle-04">
+            <a:extLst xmlns:a="http://schemas.openxmlformats.org/drawingml/2006/main">
+              <a:ext uri="{FF2B5EF4-FFF2-40B4-BE49-F238E27FC236}">
+                <a16:creationId xmlns:a16="http://schemas.microsoft.com/office/drawing/2014/main" id="{16E2FFFF-729E-4EC2-A367-31BEAE365A46}"/>
+              </a:ext>
+            </a:extLst>
+          </p:cNvPr>
+          <p:cNvSpPr>
+            <a:spLocks xmlns:a="http://schemas.openxmlformats.org/drawingml/2006/main" noGrp="1"/>
+          </p:cNvSpPr>
+          <p:nvPr/>
+        </p:nvSpPr>
+        <p:spPr>
+          <a:xfrm xmlns:a="http://schemas.openxmlformats.org/drawingml/2006/main">
+            <a:off x="742950" y="4533900"/>
+            <a:ext cx="466725" cy="466725"/>
+          </a:xfrm>
+          <a:prstGeom xmlns:a="http://schemas.openxmlformats.org/drawingml/2006/main" prst="ellipse">
+            <a:avLst/>
+          </a:prstGeom>
+          <a:solidFill xmlns:a="http://schemas.openxmlformats.org/drawingml/2006/main">
+            <a:srgbClr val="061B60"/>
+          </a:solidFill>
+          <a:ln xmlns:a="http://schemas.openxmlformats.org/drawingml/2006/main" w="0">
+            <a:noFill/>
+          </a:ln>
+        </p:spPr>
+      </p:sp>
+      <p:sp>
+        <p:nvSpPr>
+          <p:cNvPr id="16" name="number-04">
+            <a:extLst xmlns:a="http://schemas.openxmlformats.org/drawingml/2006/main">
+              <a:ext uri="{FF2B5EF4-FFF2-40B4-BE49-F238E27FC236}">
+                <a16:creationId xmlns:a16="http://schemas.microsoft.com/office/drawing/2014/main" id="{126280BE-8C0D-4C17-9E0C-CA9D916A9B87}"/>
+              </a:ext>
+            </a:extLst>
+          </p:cNvPr>
+          <p:cNvSpPr>
+            <a:spLocks xmlns:a="http://schemas.openxmlformats.org/drawingml/2006/main" noGrp="1"/>
+          </p:cNvSpPr>
+          <p:nvPr/>
+        </p:nvSpPr>
+        <p:spPr>
+          <a:xfrm xmlns:a="http://schemas.openxmlformats.org/drawingml/2006/main">
+            <a:off x="742950" y="4638675"/>
+            <a:ext cx="466725" cy="285750"/>
+          </a:xfrm>
+          <a:prstGeom xmlns:a="http://schemas.openxmlformats.org/drawingml/2006/main" prst="rect">
+            <a:avLst/>
+          </a:prstGeom>
+          <a:noFill xmlns:a="http://schemas.openxmlformats.org/drawingml/2006/main"/>
+          <a:ln xmlns:a="http://schemas.openxmlformats.org/drawingml/2006/main" w="0">
+            <a:noFill/>
+          </a:ln>
+        </p:spPr>
+        <p:txBody>
+          <a:bodyPr xmlns:a="http://schemas.openxmlformats.org/drawingml/2006/main" wrap="square" lIns="0" tIns="0" rIns="0" bIns="0" anchor="t">
+            <a:noAutofit/>
+          </a:bodyPr>
+          <a:lstStyle xmlns:a="http://schemas.openxmlformats.org/drawingml/2006/main">
+            <a:defPPr algn="ctr">
+              <a:defRPr sz="1650" b="1">
+                <a:solidFill>
+                  <a:srgbClr val="FFFFFF"/>
+                </a:solidFill>
+                <a:latin typeface="Arial"/>
+                <a:ea typeface="Arial"/>
+                <a:cs typeface="Arial"/>
+              </a:defRPr>
+            </a:defPPr>
+          </a:lstStyle>
+          <a:p xmlns:a="http://schemas.openxmlformats.org/drawingml/2006/main">
+            <a:pPr algn="ctr">
+              <a:defRPr sz="1650" b="1">
+                <a:solidFill>
+                  <a:srgbClr val="FFFFFF"/>
+                </a:solidFill>
+                <a:latin typeface="Arial"/>
+                <a:ea typeface="Arial"/>
+                <a:cs typeface="Arial"/>
+              </a:defRPr>
+            </a:pPr>
+            <a:r>
+              <a:rPr sz="1650" b="1">
+                <a:solidFill>
+                  <a:srgbClr val="FFFFFF"/>
+                </a:solidFill>
+                <a:latin typeface="Arial"/>
+                <a:ea typeface="Arial"/>
+                <a:cs typeface="Arial"/>
+              </a:rPr>
+              <a:t>04</a:t>
+            </a:r>
+          </a:p>
+        </p:txBody>
+      </p:sp>
+      <p:sp>
+        <p:nvSpPr>
+          <p:cNvPr id="17" name="heading-04">
+            <a:extLst xmlns:a="http://schemas.openxmlformats.org/drawingml/2006/main">
+              <a:ext uri="{FF2B5EF4-FFF2-40B4-BE49-F238E27FC236}">
+                <a16:creationId xmlns:a16="http://schemas.microsoft.com/office/drawing/2014/main" id="{81FBB144-F843-421E-ACAD-9D8C096D7B5D}"/>
+              </a:ext>
+            </a:extLst>
+          </p:cNvPr>
+          <p:cNvSpPr>
+            <a:spLocks xmlns:a="http://schemas.openxmlformats.org/drawingml/2006/main" noGrp="1"/>
+          </p:cNvSpPr>
+          <p:nvPr/>
+        </p:nvSpPr>
+        <p:spPr>
+          <a:xfrm xmlns:a="http://schemas.openxmlformats.org/drawingml/2006/main">
+            <a:off x="1381125" y="4514850"/>
+            <a:ext cx="7715250" cy="304800"/>
+          </a:xfrm>
+          <a:prstGeom xmlns:a="http://schemas.openxmlformats.org/drawingml/2006/main" prst="rect">
+            <a:avLst/>
+          </a:prstGeom>
+          <a:noFill xmlns:a="http://schemas.openxmlformats.org/drawingml/2006/main"/>
+          <a:ln xmlns:a="http://schemas.openxmlformats.org/drawingml/2006/main" w="0">
+            <a:noFill/>
+          </a:ln>
+        </p:spPr>
+        <p:txBody>
+          <a:bodyPr xmlns:a="http://schemas.openxmlformats.org/drawingml/2006/main" wrap="square" lIns="0" tIns="0" rIns="0" bIns="0" anchor="t">
+            <a:noAutofit/>
+          </a:bodyPr>
+          <a:lstStyle xmlns:a="http://schemas.openxmlformats.org/drawingml/2006/main">
+            <a:defPPr algn="l">
+              <a:defRPr sz="1800" b="1">
+                <a:solidFill>
+                  <a:srgbClr val="061B60"/>
+                </a:solidFill>
+                <a:latin typeface="Arial"/>
+                <a:ea typeface="Arial"/>
+                <a:cs typeface="Arial"/>
+              </a:defRPr>
+            </a:defPPr>
+          </a:lstStyle>
+          <a:p xmlns:a="http://schemas.openxmlformats.org/drawingml/2006/main">
+            <a:pPr algn="l">
+              <a:defRPr sz="1800" b="1">
+                <a:solidFill>
+                  <a:srgbClr val="061B60"/>
+                </a:solidFill>
+                <a:latin typeface="Arial"/>
+                <a:ea typeface="Arial"/>
+                <a:cs typeface="Arial"/>
+              </a:defRPr>
+            </a:pPr>
+            <a:r>
+              <a:rPr sz="1800" b="1">
+                <a:solidFill>
+                  <a:srgbClr val="061B60"/>
+                </a:solidFill>
+                <a:latin typeface="Arial"/>
+                <a:ea typeface="Arial"/>
+                <a:cs typeface="Arial"/>
+              </a:rPr>
+              <a:t>RỦI RO LỚN NHẤT &amp; CÁCH XỬ LÝ</a:t>
+            </a:r>
+          </a:p>
+        </p:txBody>
+      </p:sp>
+      <p:sp>
+        <p:nvSpPr>
+          <p:cNvPr id="18" name="body-04">
+            <a:extLst xmlns:a="http://schemas.openxmlformats.org/drawingml/2006/main">
+              <a:ext uri="{FF2B5EF4-FFF2-40B4-BE49-F238E27FC236}">
+                <a16:creationId xmlns:a16="http://schemas.microsoft.com/office/drawing/2014/main" id="{F054D139-34C6-463B-93BF-F4654D49BA95}"/>
+              </a:ext>
+            </a:extLst>
+          </p:cNvPr>
+          <p:cNvSpPr>
+            <a:spLocks xmlns:a="http://schemas.openxmlformats.org/drawingml/2006/main" noGrp="1"/>
+          </p:cNvSpPr>
+          <p:nvPr/>
+        </p:nvSpPr>
+        <p:spPr>
+          <a:xfrm xmlns:a="http://schemas.openxmlformats.org/drawingml/2006/main">
+            <a:off x="1381125" y="4886325"/>
+            <a:ext cx="7981950" cy="981075"/>
+          </a:xfrm>
+          <a:prstGeom xmlns:a="http://schemas.openxmlformats.org/drawingml/2006/main" prst="rect">
+            <a:avLst/>
+          </a:prstGeom>
+          <a:noFill xmlns:a="http://schemas.openxmlformats.org/drawingml/2006/main"/>
+          <a:ln xmlns:a="http://schemas.openxmlformats.org/drawingml/2006/main" w="0">
+            <a:noFill/>
+          </a:ln>
+        </p:spPr>
+        <p:txBody>
+          <a:bodyPr xmlns:a="http://schemas.openxmlformats.org/drawingml/2006/main" wrap="square" lIns="0" tIns="0" rIns="0" bIns="0" anchor="t">
+            <a:noAutofit/>
+          </a:bodyPr>
+          <a:lstStyle xmlns:a="http://schemas.openxmlformats.org/drawingml/2006/main">
+            <a:defPPr algn="l">
+              <a:defRPr sz="1725" b="0">
+                <a:solidFill>
+                  <a:srgbClr val="061B60"/>
+                </a:solidFill>
+                <a:latin typeface="Arial"/>
+                <a:ea typeface="Arial"/>
+                <a:cs typeface="Arial"/>
+              </a:defRPr>
+            </a:defPPr>
+          </a:lstStyle>
+          <a:p xmlns:a="http://schemas.openxmlformats.org/drawingml/2006/main">
+            <a:pPr algn="l">
+              <a:defRPr sz="1725" b="0">
+                <a:solidFill>
+                  <a:srgbClr val="061B60"/>
+                </a:solidFill>
+                <a:latin typeface="Arial"/>
+                <a:ea typeface="Arial"/>
+                <a:cs typeface="Arial"/>
+              </a:defRPr>
+            </a:pPr>
+            <a:r>
+              <a:rPr sz="1725" b="0">
+                <a:solidFill>
+                  <a:srgbClr val="061B60"/>
+                </a:solidFill>
+                <a:latin typeface="Arial"/>
+                <a:ea typeface="Arial"/>
+                <a:cs typeface="Arial"/>
+              </a:rPr>
+              <a:t>Sai mã số thuế hoặc tiền: ngừng tự nhập ngay. Duyệt mọi cờ và lấy mẫu. Nếu doanh thu dưới 3,71 triệu/văn phòng trong 2 tháng, với ít nhất 10 văn phòng, dừng mở rộng. Chưa đủ mẫu thì giữ thử nghiệm, lưu ý kịch bản hết tiền tháng 7.</a:t>
+            </a:r>
+          </a:p>
+        </p:txBody>
+      </p:sp>
+      <p:sp>
+        <p:nvSpPr>
+          <p:cNvPr id="19" name="panel-05">
+            <a:extLst xmlns:a="http://schemas.openxmlformats.org/drawingml/2006/main">
+              <a:ext uri="{FF2B5EF4-FFF2-40B4-BE49-F238E27FC236}">
+                <a16:creationId xmlns:a16="http://schemas.microsoft.com/office/drawing/2014/main" id="{CBEE3573-5A45-43AD-8243-718B26C7F6BD}"/>
+              </a:ext>
+            </a:extLst>
+          </p:cNvPr>
+          <p:cNvSpPr>
+            <a:spLocks xmlns:a="http://schemas.openxmlformats.org/drawingml/2006/main" noGrp="1"/>
+          </p:cNvSpPr>
+          <p:nvPr/>
+        </p:nvSpPr>
+        <p:spPr>
+          <a:xfrm xmlns:a="http://schemas.openxmlformats.org/drawingml/2006/main">
+            <a:off x="590550" y="6096000"/>
+            <a:ext cx="9001125" cy="1628775"/>
+          </a:xfrm>
+          <a:prstGeom xmlns:a="http://schemas.openxmlformats.org/drawingml/2006/main" prst="roundRect">
+            <a:avLst>
+              <a:gd name="adj" fmla="val 4678"/>
+            </a:avLst>
+          </a:prstGeom>
+          <a:solidFill xmlns:a="http://schemas.openxmlformats.org/drawingml/2006/main">
+            <a:srgbClr val="FFFFFF"/>
+          </a:solidFill>
+          <a:ln xmlns:a="http://schemas.openxmlformats.org/drawingml/2006/main" w="11906">
+            <a:solidFill>
+              <a:srgbClr val="8090B7"/>
+            </a:solidFill>
+          </a:ln>
+        </p:spPr>
+      </p:sp>
+      <p:sp>
+        <p:nvSpPr>
+          <p:cNvPr id="20" name="number-circle-05">
+            <a:extLst xmlns:a="http://schemas.openxmlformats.org/drawingml/2006/main">
+              <a:ext uri="{FF2B5EF4-FFF2-40B4-BE49-F238E27FC236}">
+                <a16:creationId xmlns:a16="http://schemas.microsoft.com/office/drawing/2014/main" id="{D59B71FE-8200-46BE-9386-66E80237AD04}"/>
+              </a:ext>
+            </a:extLst>
+          </p:cNvPr>
+          <p:cNvSpPr>
+            <a:spLocks xmlns:a="http://schemas.openxmlformats.org/drawingml/2006/main" noGrp="1"/>
+          </p:cNvSpPr>
+          <p:nvPr/>
+        </p:nvSpPr>
+        <p:spPr>
+          <a:xfrm xmlns:a="http://schemas.openxmlformats.org/drawingml/2006/main">
+            <a:off x="742950" y="6238875"/>
+            <a:ext cx="466725" cy="466725"/>
+          </a:xfrm>
+          <a:prstGeom xmlns:a="http://schemas.openxmlformats.org/drawingml/2006/main" prst="ellipse">
+            <a:avLst/>
+          </a:prstGeom>
+          <a:solidFill xmlns:a="http://schemas.openxmlformats.org/drawingml/2006/main">
+            <a:srgbClr val="061B60"/>
+          </a:solidFill>
+          <a:ln xmlns:a="http://schemas.openxmlformats.org/drawingml/2006/main" w="0">
+            <a:noFill/>
+          </a:ln>
+        </p:spPr>
+      </p:sp>
+      <p:sp>
+        <p:nvSpPr>
+          <p:cNvPr id="21" name="number-05">
+            <a:extLst xmlns:a="http://schemas.openxmlformats.org/drawingml/2006/main">
+              <a:ext uri="{FF2B5EF4-FFF2-40B4-BE49-F238E27FC236}">
+                <a16:creationId xmlns:a16="http://schemas.microsoft.com/office/drawing/2014/main" id="{188C7F16-4285-4E6F-A56D-61E66EF4F901}"/>
+              </a:ext>
+            </a:extLst>
+          </p:cNvPr>
+          <p:cNvSpPr>
+            <a:spLocks xmlns:a="http://schemas.openxmlformats.org/drawingml/2006/main" noGrp="1"/>
+          </p:cNvSpPr>
+          <p:nvPr/>
+        </p:nvSpPr>
+        <p:spPr>
+          <a:xfrm xmlns:a="http://schemas.openxmlformats.org/drawingml/2006/main">
+            <a:off x="742950" y="6343650"/>
+            <a:ext cx="466725" cy="285750"/>
+          </a:xfrm>
+          <a:prstGeom xmlns:a="http://schemas.openxmlformats.org/drawingml/2006/main" prst="rect">
+            <a:avLst/>
+          </a:prstGeom>
+          <a:noFill xmlns:a="http://schemas.openxmlformats.org/drawingml/2006/main"/>
+          <a:ln xmlns:a="http://schemas.openxmlformats.org/drawingml/2006/main" w="0">
+            <a:noFill/>
+          </a:ln>
+        </p:spPr>
+        <p:txBody>
+          <a:bodyPr xmlns:a="http://schemas.openxmlformats.org/drawingml/2006/main" wrap="square" lIns="0" tIns="0" rIns="0" bIns="0" anchor="t">
+            <a:noAutofit/>
+          </a:bodyPr>
+          <a:lstStyle xmlns:a="http://schemas.openxmlformats.org/drawingml/2006/main">
+            <a:defPPr algn="ctr">
+              <a:defRPr sz="1650" b="1">
+                <a:solidFill>
+                  <a:srgbClr val="FFFFFF"/>
+                </a:solidFill>
+                <a:latin typeface="Arial"/>
+                <a:ea typeface="Arial"/>
+                <a:cs typeface="Arial"/>
+              </a:defRPr>
+            </a:defPPr>
+          </a:lstStyle>
+          <a:p xmlns:a="http://schemas.openxmlformats.org/drawingml/2006/main">
+            <a:pPr algn="ctr">
+              <a:defRPr sz="1650" b="1">
+                <a:solidFill>
+                  <a:srgbClr val="FFFFFF"/>
+                </a:solidFill>
+                <a:latin typeface="Arial"/>
+                <a:ea typeface="Arial"/>
+                <a:cs typeface="Arial"/>
+              </a:defRPr>
+            </a:pPr>
+            <a:r>
+              <a:rPr sz="1650" b="1">
+                <a:solidFill>
+                  <a:srgbClr val="FFFFFF"/>
+                </a:solidFill>
+                <a:latin typeface="Arial"/>
+                <a:ea typeface="Arial"/>
+                <a:cs typeface="Arial"/>
+              </a:rPr>
+              <a:t>05</a:t>
+            </a:r>
+          </a:p>
+        </p:txBody>
+      </p:sp>
+      <p:sp>
+        <p:nvSpPr>
+          <p:cNvPr id="22" name="heading-05">
+            <a:extLst xmlns:a="http://schemas.openxmlformats.org/drawingml/2006/main">
+              <a:ext uri="{FF2B5EF4-FFF2-40B4-BE49-F238E27FC236}">
+                <a16:creationId xmlns:a16="http://schemas.microsoft.com/office/drawing/2014/main" id="{B472D5C5-E976-4C1C-83D8-23E463904D73}"/>
+              </a:ext>
+            </a:extLst>
+          </p:cNvPr>
+          <p:cNvSpPr>
+            <a:spLocks xmlns:a="http://schemas.openxmlformats.org/drawingml/2006/main" noGrp="1"/>
+          </p:cNvSpPr>
+          <p:nvPr/>
+        </p:nvSpPr>
+        <p:spPr>
+          <a:xfrm xmlns:a="http://schemas.openxmlformats.org/drawingml/2006/main">
+            <a:off x="1381125" y="6219825"/>
+            <a:ext cx="7715250" cy="304800"/>
+          </a:xfrm>
+          <a:prstGeom xmlns:a="http://schemas.openxmlformats.org/drawingml/2006/main" prst="rect">
+            <a:avLst/>
+          </a:prstGeom>
+          <a:noFill xmlns:a="http://schemas.openxmlformats.org/drawingml/2006/main"/>
+          <a:ln xmlns:a="http://schemas.openxmlformats.org/drawingml/2006/main" w="0">
+            <a:noFill/>
+          </a:ln>
+        </p:spPr>
+        <p:txBody>
+          <a:bodyPr xmlns:a="http://schemas.openxmlformats.org/drawingml/2006/main" wrap="square" lIns="0" tIns="0" rIns="0" bIns="0" anchor="t">
+            <a:noAutofit/>
+          </a:bodyPr>
+          <a:lstStyle xmlns:a="http://schemas.openxmlformats.org/drawingml/2006/main">
+            <a:defPPr algn="l">
+              <a:defRPr sz="1800" b="1">
+                <a:solidFill>
+                  <a:srgbClr val="061B60"/>
+                </a:solidFill>
+                <a:latin typeface="Arial"/>
+                <a:ea typeface="Arial"/>
+                <a:cs typeface="Arial"/>
+              </a:defRPr>
+            </a:defPPr>
+          </a:lstStyle>
+          <a:p xmlns:a="http://schemas.openxmlformats.org/drawingml/2006/main">
+            <a:pPr algn="l">
+              <a:defRPr sz="1800" b="1">
+                <a:solidFill>
+                  <a:srgbClr val="061B60"/>
+                </a:solidFill>
+                <a:latin typeface="Arial"/>
+                <a:ea typeface="Arial"/>
+                <a:cs typeface="Arial"/>
+              </a:defRPr>
+            </a:pPr>
+            <a:r>
+              <a:rPr sz="1800" b="1">
+                <a:solidFill>
+                  <a:srgbClr val="061B60"/>
+                </a:solidFill>
+                <a:latin typeface="Arial"/>
+                <a:ea typeface="Arial"/>
+                <a:cs typeface="Arial"/>
+              </a:rPr>
+              <a:t>KHI NÀO XEM LẠI</a:t>
+            </a:r>
+          </a:p>
+        </p:txBody>
+      </p:sp>
+      <p:sp>
+        <p:nvSpPr>
+          <p:cNvPr id="23" name="body-05">
+            <a:extLst xmlns:a="http://schemas.openxmlformats.org/drawingml/2006/main">
+              <a:ext uri="{FF2B5EF4-FFF2-40B4-BE49-F238E27FC236}">
+                <a16:creationId xmlns:a16="http://schemas.microsoft.com/office/drawing/2014/main" id="{A0DDF751-3788-46E1-B8E1-64CCC0C9C2C4}"/>
+              </a:ext>
+            </a:extLst>
+          </p:cNvPr>
+          <p:cNvSpPr>
+            <a:spLocks xmlns:a="http://schemas.openxmlformats.org/drawingml/2006/main" noGrp="1"/>
+          </p:cNvSpPr>
+          <p:nvPr/>
+        </p:nvSpPr>
+        <p:spPr>
+          <a:xfrm xmlns:a="http://schemas.openxmlformats.org/drawingml/2006/main">
+            <a:off x="1381125" y="6591300"/>
+            <a:ext cx="7981950" cy="1057275"/>
+          </a:xfrm>
+          <a:prstGeom xmlns:a="http://schemas.openxmlformats.org/drawingml/2006/main" prst="rect">
+            <a:avLst/>
+          </a:prstGeom>
+          <a:noFill xmlns:a="http://schemas.openxmlformats.org/drawingml/2006/main"/>
+          <a:ln xmlns:a="http://schemas.openxmlformats.org/drawingml/2006/main" w="0">
+            <a:noFill/>
+          </a:ln>
+        </p:spPr>
+        <p:txBody>
+          <a:bodyPr xmlns:a="http://schemas.openxmlformats.org/drawingml/2006/main" wrap="square" lIns="0" tIns="0" rIns="0" bIns="0" anchor="t">
+            <a:noAutofit/>
+          </a:bodyPr>
+          <a:lstStyle xmlns:a="http://schemas.openxmlformats.org/drawingml/2006/main">
+            <a:defPPr algn="l">
+              <a:defRPr sz="1725" b="0">
+                <a:solidFill>
+                  <a:srgbClr val="061B60"/>
+                </a:solidFill>
+                <a:latin typeface="Arial"/>
+                <a:ea typeface="Arial"/>
+                <a:cs typeface="Arial"/>
+              </a:defRPr>
+            </a:defPPr>
+          </a:lstStyle>
+          <a:p xmlns:a="http://schemas.openxmlformats.org/drawingml/2006/main">
+            <a:pPr algn="l">
+              <a:defRPr sz="1725" b="0">
+                <a:solidFill>
+                  <a:srgbClr val="061B60"/>
+                </a:solidFill>
+                <a:latin typeface="Arial"/>
+                <a:ea typeface="Arial"/>
+                <a:cs typeface="Arial"/>
+              </a:defRPr>
+            </a:pPr>
+            <a:r>
+              <a:rPr sz="1725" b="0">
+                <a:solidFill>
+                  <a:srgbClr val="061B60"/>
+                </a:solidFill>
+                <a:latin typeface="Arial"/>
+                <a:ea typeface="Arial"/>
+                <a:cs typeface="Arial"/>
+              </a:rPr>
+              <a:t>Ngày 30/60/90 từ lúc bắt đầu: xem lỗi, cờ thừa, giờ nhập và chi phí. Mức 2 cần 0 lỗi nghiêm trọng/300 hóa đơn kiểm tra, đạt từ 95%, không tầng tụt. Mô hình, giá hoặc quy định đổi: rà soát ngay. Các ngưỡng mới là đề xuất cần kiểm chứng.</a:t>
+            </a:r>
+          </a:p>
+        </p:txBody>
+      </p:sp>
+      <p:sp>
+        <p:nvSpPr>
+          <p:cNvPr id="24" name="roadmap-heading">
+            <a:extLst xmlns:a="http://schemas.openxmlformats.org/drawingml/2006/main">
+              <a:ext uri="{FF2B5EF4-FFF2-40B4-BE49-F238E27FC236}">
+                <a16:creationId xmlns:a16="http://schemas.microsoft.com/office/drawing/2014/main" id="{F6F6C050-4417-43D9-883F-41CCCC3DF481}"/>
+              </a:ext>
+            </a:extLst>
+          </p:cNvPr>
+          <p:cNvSpPr>
+            <a:spLocks xmlns:a="http://schemas.openxmlformats.org/drawingml/2006/main" noGrp="1"/>
+          </p:cNvSpPr>
+          <p:nvPr/>
+        </p:nvSpPr>
+        <p:spPr>
+          <a:xfrm xmlns:a="http://schemas.openxmlformats.org/drawingml/2006/main">
+            <a:off x="9944100" y="2724150"/>
+            <a:ext cx="4572000" cy="381000"/>
+          </a:xfrm>
+          <a:prstGeom xmlns:a="http://schemas.openxmlformats.org/drawingml/2006/main" prst="rect">
+            <a:avLst/>
+          </a:prstGeom>
+          <a:noFill xmlns:a="http://schemas.openxmlformats.org/drawingml/2006/main"/>
+          <a:ln xmlns:a="http://schemas.openxmlformats.org/drawingml/2006/main" w="0">
+            <a:noFill/>
+          </a:ln>
+        </p:spPr>
+        <p:txBody>
+          <a:bodyPr xmlns:a="http://schemas.openxmlformats.org/drawingml/2006/main" wrap="square" lIns="0" tIns="0" rIns="0" bIns="0" anchor="t">
+            <a:noAutofit/>
+          </a:bodyPr>
+          <a:lstStyle xmlns:a="http://schemas.openxmlformats.org/drawingml/2006/main">
+            <a:defPPr algn="l">
+              <a:defRPr sz="2100" b="1">
+                <a:solidFill>
+                  <a:srgbClr val="061B60"/>
+                </a:solidFill>
+                <a:latin typeface="Arial"/>
+                <a:ea typeface="Arial"/>
+                <a:cs typeface="Arial"/>
+              </a:defRPr>
+            </a:defPPr>
+          </a:lstStyle>
+          <a:p xmlns:a="http://schemas.openxmlformats.org/drawingml/2006/main">
+            <a:pPr algn="l">
+              <a:defRPr sz="2100" b="1">
+                <a:solidFill>
+                  <a:srgbClr val="061B60"/>
+                </a:solidFill>
+                <a:latin typeface="Arial"/>
+                <a:ea typeface="Arial"/>
+                <a:cs typeface="Arial"/>
+              </a:defRPr>
+            </a:pPr>
+            <a:r>
+              <a:rPr sz="2100" b="1">
+                <a:solidFill>
+                  <a:srgbClr val="061B60"/>
+                </a:solidFill>
+                <a:latin typeface="Arial"/>
+                <a:ea typeface="Arial"/>
+                <a:cs typeface="Arial"/>
+              </a:rPr>
+              <a:t>02  3 VIỆC CHÍNH</a:t>
+            </a:r>
+          </a:p>
+        </p:txBody>
+      </p:sp>
+      <p:sp>
+        <p:nvSpPr>
+          <p:cNvPr id="25" name="stage-0">
+            <a:extLst xmlns:a="http://schemas.openxmlformats.org/drawingml/2006/main">
+              <a:ext uri="{FF2B5EF4-FFF2-40B4-BE49-F238E27FC236}">
+                <a16:creationId xmlns:a16="http://schemas.microsoft.com/office/drawing/2014/main" id="{CC2A97D1-D8BB-40EE-9ED7-CDC1B1C57A07}"/>
+              </a:ext>
+            </a:extLst>
+          </p:cNvPr>
+          <p:cNvSpPr>
+            <a:spLocks xmlns:a="http://schemas.openxmlformats.org/drawingml/2006/main" noGrp="1"/>
+          </p:cNvSpPr>
+          <p:nvPr/>
+        </p:nvSpPr>
+        <p:spPr>
+          <a:xfrm xmlns:a="http://schemas.openxmlformats.org/drawingml/2006/main">
+            <a:off x="9944100" y="3286125"/>
+            <a:ext cx="4695825" cy="1200150"/>
+          </a:xfrm>
+          <a:prstGeom xmlns:a="http://schemas.openxmlformats.org/drawingml/2006/main" prst="roundRect">
+            <a:avLst>
+              <a:gd name="adj" fmla="val 6349"/>
+            </a:avLst>
+          </a:prstGeom>
+          <a:solidFill xmlns:a="http://schemas.openxmlformats.org/drawingml/2006/main">
+            <a:srgbClr val="061B60"/>
+          </a:solidFill>
+          <a:ln xmlns:a="http://schemas.openxmlformats.org/drawingml/2006/main" w="0">
+            <a:noFill/>
+          </a:ln>
+        </p:spPr>
+      </p:sp>
+      <p:sp>
+        <p:nvSpPr>
+          <p:cNvPr id="26" name="stage-period-0">
+            <a:extLst xmlns:a="http://schemas.openxmlformats.org/drawingml/2006/main">
+              <a:ext uri="{FF2B5EF4-FFF2-40B4-BE49-F238E27FC236}">
+                <a16:creationId xmlns:a16="http://schemas.microsoft.com/office/drawing/2014/main" id="{F4A6FD50-1F54-44B0-8B8C-21867F653330}"/>
+              </a:ext>
+            </a:extLst>
+          </p:cNvPr>
+          <p:cNvSpPr>
+            <a:spLocks xmlns:a="http://schemas.openxmlformats.org/drawingml/2006/main" noGrp="1"/>
+          </p:cNvSpPr>
+          <p:nvPr/>
+        </p:nvSpPr>
+        <p:spPr>
+          <a:xfrm xmlns:a="http://schemas.openxmlformats.org/drawingml/2006/main">
+            <a:off x="10163175" y="3419475"/>
+            <a:ext cx="4257675" cy="333375"/>
+          </a:xfrm>
+          <a:prstGeom xmlns:a="http://schemas.openxmlformats.org/drawingml/2006/main" prst="rect">
+            <a:avLst/>
+          </a:prstGeom>
+          <a:noFill xmlns:a="http://schemas.openxmlformats.org/drawingml/2006/main"/>
+          <a:ln xmlns:a="http://schemas.openxmlformats.org/drawingml/2006/main" w="0">
+            <a:noFill/>
+          </a:ln>
+        </p:spPr>
+        <p:txBody>
+          <a:bodyPr xmlns:a="http://schemas.openxmlformats.org/drawingml/2006/main" wrap="square" lIns="0" tIns="0" rIns="0" bIns="0" anchor="t">
+            <a:noAutofit/>
+          </a:bodyPr>
+          <a:lstStyle xmlns:a="http://schemas.openxmlformats.org/drawingml/2006/main">
+            <a:defPPr algn="ctr">
+              <a:defRPr sz="2025" b="1">
+                <a:solidFill>
+                  <a:srgbClr val="FFFFFF"/>
+                </a:solidFill>
+                <a:latin typeface="Arial"/>
+                <a:ea typeface="Arial"/>
+                <a:cs typeface="Arial"/>
+              </a:defRPr>
+            </a:defPPr>
+          </a:lstStyle>
+          <a:p xmlns:a="http://schemas.openxmlformats.org/drawingml/2006/main">
+            <a:pPr algn="ctr">
+              <a:defRPr sz="2025" b="1">
+                <a:solidFill>
+                  <a:srgbClr val="FFFFFF"/>
+                </a:solidFill>
+                <a:latin typeface="Arial"/>
+                <a:ea typeface="Arial"/>
+                <a:cs typeface="Arial"/>
+              </a:defRPr>
+            </a:pPr>
+            <a:r>
+              <a:rPr sz="2025" b="1">
+                <a:solidFill>
+                  <a:srgbClr val="FFFFFF"/>
+                </a:solidFill>
+                <a:latin typeface="Arial"/>
+                <a:ea typeface="Arial"/>
+                <a:cs typeface="Arial"/>
+              </a:rPr>
+              <a:t>0–3 THÁNG</a:t>
+            </a:r>
+          </a:p>
+        </p:txBody>
+      </p:sp>
+      <p:sp>
+        <p:nvSpPr>
+          <p:cNvPr id="27" name="stage-body-0">
+            <a:extLst xmlns:a="http://schemas.openxmlformats.org/drawingml/2006/main">
+              <a:ext uri="{FF2B5EF4-FFF2-40B4-BE49-F238E27FC236}">
+                <a16:creationId xmlns:a16="http://schemas.microsoft.com/office/drawing/2014/main" id="{C427823A-48E9-46DE-9276-670A7F6F791D}"/>
+              </a:ext>
+            </a:extLst>
+          </p:cNvPr>
+          <p:cNvSpPr>
+            <a:spLocks xmlns:a="http://schemas.openxmlformats.org/drawingml/2006/main" noGrp="1"/>
+          </p:cNvSpPr>
+          <p:nvPr/>
+        </p:nvSpPr>
+        <p:spPr>
+          <a:xfrm xmlns:a="http://schemas.openxmlformats.org/drawingml/2006/main">
+            <a:off x="10163175" y="3800475"/>
+            <a:ext cx="4257675" cy="628650"/>
+          </a:xfrm>
+          <a:prstGeom xmlns:a="http://schemas.openxmlformats.org/drawingml/2006/main" prst="rect">
+            <a:avLst/>
+          </a:prstGeom>
+          <a:noFill xmlns:a="http://schemas.openxmlformats.org/drawingml/2006/main"/>
+          <a:ln xmlns:a="http://schemas.openxmlformats.org/drawingml/2006/main" w="0">
+            <a:noFill/>
+          </a:ln>
+        </p:spPr>
+        <p:txBody>
+          <a:bodyPr xmlns:a="http://schemas.openxmlformats.org/drawingml/2006/main" wrap="square" lIns="0" tIns="0" rIns="0" bIns="0" anchor="t">
+            <a:noAutofit/>
+          </a:bodyPr>
+          <a:lstStyle xmlns:a="http://schemas.openxmlformats.org/drawingml/2006/main">
+            <a:defPPr algn="ctr">
+              <a:defRPr sz="1763" b="0">
+                <a:solidFill>
+                  <a:srgbClr val="FFFFFF"/>
+                </a:solidFill>
+                <a:latin typeface="Arial"/>
+                <a:ea typeface="Arial"/>
+                <a:cs typeface="Arial"/>
+              </a:defRPr>
+            </a:defPPr>
+          </a:lstStyle>
+          <a:p xmlns:a="http://schemas.openxmlformats.org/drawingml/2006/main">
+            <a:pPr algn="ctr">
+              <a:defRPr sz="1763" b="0">
+                <a:solidFill>
+                  <a:srgbClr val="FFFFFF"/>
+                </a:solidFill>
+                <a:latin typeface="Arial"/>
+                <a:ea typeface="Arial"/>
+                <a:cs typeface="Arial"/>
+              </a:defRPr>
+            </a:pPr>
+            <a:r>
+              <a:rPr sz="1763" b="0">
+                <a:solidFill>
+                  <a:srgbClr val="FFFFFF"/>
+                </a:solidFill>
+                <a:latin typeface="Arial"/>
+                <a:ea typeface="Arial"/>
+                <a:cs typeface="Arial"/>
+              </a:rPr>
+              <a:t>đọc ảnh và gắn cờ.</a:t>
+            </a:r>
+          </a:p>
+        </p:txBody>
+      </p:sp>
+      <p:sp>
+        <p:nvSpPr>
+          <p:cNvPr id="28" name="stage-connector-0">
+            <a:extLst xmlns:a="http://schemas.openxmlformats.org/drawingml/2006/main">
+              <a:ext uri="{FF2B5EF4-FFF2-40B4-BE49-F238E27FC236}">
+                <a16:creationId xmlns:a16="http://schemas.microsoft.com/office/drawing/2014/main" id="{64DCEF97-4E08-4A30-AA12-9A1837082D45}"/>
+              </a:ext>
+            </a:extLst>
+          </p:cNvPr>
+          <p:cNvSpPr>
+            <a:spLocks xmlns:a="http://schemas.openxmlformats.org/drawingml/2006/main" noGrp="1"/>
+          </p:cNvSpPr>
+          <p:nvPr/>
+        </p:nvSpPr>
+        <p:spPr>
+          <a:xfrm xmlns:a="http://schemas.openxmlformats.org/drawingml/2006/main">
+            <a:off x="12172950" y="4524375"/>
+            <a:ext cx="228600" cy="114300"/>
+          </a:xfrm>
+          <a:prstGeom xmlns:a="http://schemas.openxmlformats.org/drawingml/2006/main" prst="downArrow">
+            <a:avLst/>
+          </a:prstGeom>
+          <a:solidFill xmlns:a="http://schemas.openxmlformats.org/drawingml/2006/main">
+            <a:srgbClr val="81D8E5"/>
+          </a:solidFill>
+          <a:ln xmlns:a="http://schemas.openxmlformats.org/drawingml/2006/main" w="0">
+            <a:noFill/>
+          </a:ln>
+        </p:spPr>
+      </p:sp>
+      <p:sp>
+        <p:nvSpPr>
+          <p:cNvPr id="29" name="stage-1">
+            <a:extLst xmlns:a="http://schemas.openxmlformats.org/drawingml/2006/main">
+              <a:ext uri="{FF2B5EF4-FFF2-40B4-BE49-F238E27FC236}">
+                <a16:creationId xmlns:a16="http://schemas.microsoft.com/office/drawing/2014/main" id="{D3AB1651-C71E-4211-8239-B64B1C8371B8}"/>
+              </a:ext>
+            </a:extLst>
+          </p:cNvPr>
+          <p:cNvSpPr>
+            <a:spLocks xmlns:a="http://schemas.openxmlformats.org/drawingml/2006/main" noGrp="1"/>
+          </p:cNvSpPr>
+          <p:nvPr/>
+        </p:nvSpPr>
+        <p:spPr>
+          <a:xfrm xmlns:a="http://schemas.openxmlformats.org/drawingml/2006/main">
+            <a:off x="9944100" y="4657725"/>
+            <a:ext cx="4695825" cy="1200150"/>
+          </a:xfrm>
+          <a:prstGeom xmlns:a="http://schemas.openxmlformats.org/drawingml/2006/main" prst="roundRect">
+            <a:avLst>
+              <a:gd name="adj" fmla="val 6349"/>
+            </a:avLst>
+          </a:prstGeom>
+          <a:solidFill xmlns:a="http://schemas.openxmlformats.org/drawingml/2006/main">
+            <a:srgbClr val="1552A4"/>
+          </a:solidFill>
+          <a:ln xmlns:a="http://schemas.openxmlformats.org/drawingml/2006/main" w="0">
+            <a:noFill/>
+          </a:ln>
+        </p:spPr>
+      </p:sp>
+      <p:sp>
+        <p:nvSpPr>
+          <p:cNvPr id="30" name="stage-period-1">
+            <a:extLst xmlns:a="http://schemas.openxmlformats.org/drawingml/2006/main">
+              <a:ext uri="{FF2B5EF4-FFF2-40B4-BE49-F238E27FC236}">
+                <a16:creationId xmlns:a16="http://schemas.microsoft.com/office/drawing/2014/main" id="{EAA0B83E-507B-49B8-8828-B06F90005FA2}"/>
+              </a:ext>
+            </a:extLst>
+          </p:cNvPr>
+          <p:cNvSpPr>
+            <a:spLocks xmlns:a="http://schemas.openxmlformats.org/drawingml/2006/main" noGrp="1"/>
+          </p:cNvSpPr>
+          <p:nvPr/>
+        </p:nvSpPr>
+        <p:spPr>
+          <a:xfrm xmlns:a="http://schemas.openxmlformats.org/drawingml/2006/main">
+            <a:off x="10163175" y="4791075"/>
+            <a:ext cx="4257675" cy="333375"/>
+          </a:xfrm>
+          <a:prstGeom xmlns:a="http://schemas.openxmlformats.org/drawingml/2006/main" prst="rect">
+            <a:avLst/>
+          </a:prstGeom>
+          <a:noFill xmlns:a="http://schemas.openxmlformats.org/drawingml/2006/main"/>
+          <a:ln xmlns:a="http://schemas.openxmlformats.org/drawingml/2006/main" w="0">
+            <a:noFill/>
+          </a:ln>
+        </p:spPr>
+        <p:txBody>
+          <a:bodyPr xmlns:a="http://schemas.openxmlformats.org/drawingml/2006/main" wrap="square" lIns="0" tIns="0" rIns="0" bIns="0" anchor="t">
+            <a:noAutofit/>
+          </a:bodyPr>
+          <a:lstStyle xmlns:a="http://schemas.openxmlformats.org/drawingml/2006/main">
+            <a:defPPr algn="ctr">
+              <a:defRPr sz="2025" b="1">
+                <a:solidFill>
+                  <a:srgbClr val="FFFFFF"/>
+                </a:solidFill>
+                <a:latin typeface="Arial"/>
+                <a:ea typeface="Arial"/>
+                <a:cs typeface="Arial"/>
+              </a:defRPr>
+            </a:defPPr>
+          </a:lstStyle>
+          <a:p xmlns:a="http://schemas.openxmlformats.org/drawingml/2006/main">
+            <a:pPr algn="ctr">
+              <a:defRPr sz="2025" b="1">
+                <a:solidFill>
+                  <a:srgbClr val="FFFFFF"/>
+                </a:solidFill>
+                <a:latin typeface="Arial"/>
+                <a:ea typeface="Arial"/>
+                <a:cs typeface="Arial"/>
+              </a:defRPr>
+            </a:pPr>
+            <a:r>
+              <a:rPr sz="2025" b="1">
+                <a:solidFill>
+                  <a:srgbClr val="FFFFFF"/>
+                </a:solidFill>
+                <a:latin typeface="Arial"/>
+                <a:ea typeface="Arial"/>
+                <a:cs typeface="Arial"/>
+              </a:rPr>
+              <a:t>3–6 THÁNG</a:t>
+            </a:r>
+          </a:p>
+        </p:txBody>
+      </p:sp>
+      <p:sp>
+        <p:nvSpPr>
+          <p:cNvPr id="31" name="stage-body-1">
+            <a:extLst xmlns:a="http://schemas.openxmlformats.org/drawingml/2006/main">
+              <a:ext uri="{FF2B5EF4-FFF2-40B4-BE49-F238E27FC236}">
+                <a16:creationId xmlns:a16="http://schemas.microsoft.com/office/drawing/2014/main" id="{B34CB3F9-0D40-4C40-8E56-9EB53D8E0DE6}"/>
+              </a:ext>
+            </a:extLst>
+          </p:cNvPr>
+          <p:cNvSpPr>
+            <a:spLocks xmlns:a="http://schemas.openxmlformats.org/drawingml/2006/main" noGrp="1"/>
+          </p:cNvSpPr>
+          <p:nvPr/>
+        </p:nvSpPr>
+        <p:spPr>
+          <a:xfrm xmlns:a="http://schemas.openxmlformats.org/drawingml/2006/main">
+            <a:off x="10163175" y="5172075"/>
+            <a:ext cx="4257675" cy="628650"/>
+          </a:xfrm>
+          <a:prstGeom xmlns:a="http://schemas.openxmlformats.org/drawingml/2006/main" prst="rect">
+            <a:avLst/>
+          </a:prstGeom>
+          <a:noFill xmlns:a="http://schemas.openxmlformats.org/drawingml/2006/main"/>
+          <a:ln xmlns:a="http://schemas.openxmlformats.org/drawingml/2006/main" w="0">
+            <a:noFill/>
+          </a:ln>
+        </p:spPr>
+        <p:txBody>
+          <a:bodyPr xmlns:a="http://schemas.openxmlformats.org/drawingml/2006/main" wrap="square" lIns="0" tIns="0" rIns="0" bIns="0" anchor="t">
+            <a:noAutofit/>
+          </a:bodyPr>
+          <a:lstStyle xmlns:a="http://schemas.openxmlformats.org/drawingml/2006/main">
+            <a:defPPr algn="ctr">
+              <a:defRPr sz="1763" b="0">
+                <a:solidFill>
+                  <a:srgbClr val="FFFFFF"/>
+                </a:solidFill>
+                <a:latin typeface="Arial"/>
+                <a:ea typeface="Arial"/>
+                <a:cs typeface="Arial"/>
+              </a:defRPr>
+            </a:defPPr>
+          </a:lstStyle>
+          <a:p xmlns:a="http://schemas.openxmlformats.org/drawingml/2006/main">
+            <a:pPr algn="ctr">
+              <a:defRPr sz="1763" b="0">
+                <a:solidFill>
+                  <a:srgbClr val="FFFFFF"/>
+                </a:solidFill>
+                <a:latin typeface="Arial"/>
+                <a:ea typeface="Arial"/>
+                <a:cs typeface="Arial"/>
+              </a:defRPr>
+            </a:pPr>
+            <a:r>
+              <a:rPr sz="1763" b="0">
+                <a:solidFill>
+                  <a:srgbClr val="FFFFFF"/>
+                </a:solidFill>
+                <a:latin typeface="Arial"/>
+                <a:ea typeface="Arial"/>
+                <a:cs typeface="Arial"/>
+              </a:rPr>
+              <a:t>đối chiếu mã số thuế, tích hợp dịch vụ sẵn có.</a:t>
+            </a:r>
+          </a:p>
+        </p:txBody>
+      </p:sp>
+      <p:sp>
+        <p:nvSpPr>
+          <p:cNvPr id="32" name="stage-connector-1">
+            <a:extLst xmlns:a="http://schemas.openxmlformats.org/drawingml/2006/main">
+              <a:ext uri="{FF2B5EF4-FFF2-40B4-BE49-F238E27FC236}">
+                <a16:creationId xmlns:a16="http://schemas.microsoft.com/office/drawing/2014/main" id="{4E464F5C-F402-4B7E-AC32-D1C9739ECD0C}"/>
+              </a:ext>
+            </a:extLst>
+          </p:cNvPr>
+          <p:cNvSpPr>
+            <a:spLocks xmlns:a="http://schemas.openxmlformats.org/drawingml/2006/main" noGrp="1"/>
+          </p:cNvSpPr>
+          <p:nvPr/>
+        </p:nvSpPr>
+        <p:spPr>
+          <a:xfrm xmlns:a="http://schemas.openxmlformats.org/drawingml/2006/main">
+            <a:off x="12172950" y="5895975"/>
+            <a:ext cx="228600" cy="114300"/>
+          </a:xfrm>
+          <a:prstGeom xmlns:a="http://schemas.openxmlformats.org/drawingml/2006/main" prst="downArrow">
+            <a:avLst/>
+          </a:prstGeom>
+          <a:solidFill xmlns:a="http://schemas.openxmlformats.org/drawingml/2006/main">
+            <a:srgbClr val="81D8E5"/>
+          </a:solidFill>
+          <a:ln xmlns:a="http://schemas.openxmlformats.org/drawingml/2006/main" w="0">
+            <a:noFill/>
+          </a:ln>
+        </p:spPr>
+      </p:sp>
+      <p:sp>
+        <p:nvSpPr>
+          <p:cNvPr id="33" name="stage-2">
+            <a:extLst xmlns:a="http://schemas.openxmlformats.org/drawingml/2006/main">
+              <a:ext uri="{FF2B5EF4-FFF2-40B4-BE49-F238E27FC236}">
+                <a16:creationId xmlns:a16="http://schemas.microsoft.com/office/drawing/2014/main" id="{987F2A08-6EAD-44EB-B0CD-E2D1A7BA9418}"/>
+              </a:ext>
+            </a:extLst>
+          </p:cNvPr>
+          <p:cNvSpPr>
+            <a:spLocks xmlns:a="http://schemas.openxmlformats.org/drawingml/2006/main" noGrp="1"/>
+          </p:cNvSpPr>
+          <p:nvPr/>
+        </p:nvSpPr>
+        <p:spPr>
+          <a:xfrm xmlns:a="http://schemas.openxmlformats.org/drawingml/2006/main">
+            <a:off x="9944100" y="6029325"/>
+            <a:ext cx="4695825" cy="1200150"/>
+          </a:xfrm>
+          <a:prstGeom xmlns:a="http://schemas.openxmlformats.org/drawingml/2006/main" prst="roundRect">
+            <a:avLst>
+              <a:gd name="adj" fmla="val 6349"/>
+            </a:avLst>
+          </a:prstGeom>
+          <a:solidFill xmlns:a="http://schemas.openxmlformats.org/drawingml/2006/main">
+            <a:srgbClr val="009FB8"/>
+          </a:solidFill>
+          <a:ln xmlns:a="http://schemas.openxmlformats.org/drawingml/2006/main" w="0">
+            <a:noFill/>
+          </a:ln>
+        </p:spPr>
+      </p:sp>
+      <p:sp>
+        <p:nvSpPr>
+          <p:cNvPr id="34" name="stage-period-2">
+            <a:extLst xmlns:a="http://schemas.openxmlformats.org/drawingml/2006/main">
+              <a:ext uri="{FF2B5EF4-FFF2-40B4-BE49-F238E27FC236}">
+                <a16:creationId xmlns:a16="http://schemas.microsoft.com/office/drawing/2014/main" id="{068B125F-1EC6-4D73-BD5E-DBF320A6C088}"/>
+              </a:ext>
+            </a:extLst>
+          </p:cNvPr>
+          <p:cNvSpPr>
+            <a:spLocks xmlns:a="http://schemas.openxmlformats.org/drawingml/2006/main" noGrp="1"/>
+          </p:cNvSpPr>
+          <p:nvPr/>
+        </p:nvSpPr>
+        <p:spPr>
+          <a:xfrm xmlns:a="http://schemas.openxmlformats.org/drawingml/2006/main">
+            <a:off x="10163175" y="6162675"/>
+            <a:ext cx="4257675" cy="333375"/>
+          </a:xfrm>
+          <a:prstGeom xmlns:a="http://schemas.openxmlformats.org/drawingml/2006/main" prst="rect">
+            <a:avLst/>
+          </a:prstGeom>
+          <a:noFill xmlns:a="http://schemas.openxmlformats.org/drawingml/2006/main"/>
+          <a:ln xmlns:a="http://schemas.openxmlformats.org/drawingml/2006/main" w="0">
+            <a:noFill/>
+          </a:ln>
+        </p:spPr>
+        <p:txBody>
+          <a:bodyPr xmlns:a="http://schemas.openxmlformats.org/drawingml/2006/main" wrap="square" lIns="0" tIns="0" rIns="0" bIns="0" anchor="t">
+            <a:noAutofit/>
+          </a:bodyPr>
+          <a:lstStyle xmlns:a="http://schemas.openxmlformats.org/drawingml/2006/main">
+            <a:defPPr algn="ctr">
+              <a:defRPr sz="2025" b="1">
+                <a:solidFill>
+                  <a:srgbClr val="FFFFFF"/>
+                </a:solidFill>
+                <a:latin typeface="Arial"/>
+                <a:ea typeface="Arial"/>
+                <a:cs typeface="Arial"/>
+              </a:defRPr>
+            </a:defPPr>
+          </a:lstStyle>
+          <a:p xmlns:a="http://schemas.openxmlformats.org/drawingml/2006/main">
+            <a:pPr algn="ctr">
+              <a:defRPr sz="2025" b="1">
+                <a:solidFill>
+                  <a:srgbClr val="FFFFFF"/>
+                </a:solidFill>
+                <a:latin typeface="Arial"/>
+                <a:ea typeface="Arial"/>
+                <a:cs typeface="Arial"/>
+              </a:defRPr>
+            </a:pPr>
+            <a:r>
+              <a:rPr sz="2025" b="1">
+                <a:solidFill>
+                  <a:srgbClr val="FFFFFF"/>
+                </a:solidFill>
+                <a:latin typeface="Arial"/>
+                <a:ea typeface="Arial"/>
+                <a:cs typeface="Arial"/>
+              </a:rPr>
+              <a:t>6–12 THÁNG</a:t>
+            </a:r>
+          </a:p>
+        </p:txBody>
+      </p:sp>
+      <p:sp>
+        <p:nvSpPr>
+          <p:cNvPr id="35" name="stage-body-2">
+            <a:extLst xmlns:a="http://schemas.openxmlformats.org/drawingml/2006/main">
+              <a:ext uri="{FF2B5EF4-FFF2-40B4-BE49-F238E27FC236}">
+                <a16:creationId xmlns:a16="http://schemas.microsoft.com/office/drawing/2014/main" id="{5DC09209-B3E1-4CCE-A777-CBDE0A797041}"/>
+              </a:ext>
+            </a:extLst>
+          </p:cNvPr>
+          <p:cNvSpPr>
+            <a:spLocks xmlns:a="http://schemas.openxmlformats.org/drawingml/2006/main" noGrp="1"/>
+          </p:cNvSpPr>
+          <p:nvPr/>
+        </p:nvSpPr>
+        <p:spPr>
+          <a:xfrm xmlns:a="http://schemas.openxmlformats.org/drawingml/2006/main">
+            <a:off x="10163175" y="6543675"/>
+            <a:ext cx="4257675" cy="628650"/>
+          </a:xfrm>
+          <a:prstGeom xmlns:a="http://schemas.openxmlformats.org/drawingml/2006/main" prst="rect">
+            <a:avLst/>
+          </a:prstGeom>
+          <a:noFill xmlns:a="http://schemas.openxmlformats.org/drawingml/2006/main"/>
+          <a:ln xmlns:a="http://schemas.openxmlformats.org/drawingml/2006/main" w="0">
+            <a:noFill/>
+          </a:ln>
+        </p:spPr>
+        <p:txBody>
+          <a:bodyPr xmlns:a="http://schemas.openxmlformats.org/drawingml/2006/main" wrap="square" lIns="0" tIns="0" rIns="0" bIns="0" anchor="t">
+            <a:noAutofit/>
+          </a:bodyPr>
+          <a:lstStyle xmlns:a="http://schemas.openxmlformats.org/drawingml/2006/main">
+            <a:defPPr algn="ctr">
+              <a:defRPr sz="1763" b="0">
+                <a:solidFill>
+                  <a:srgbClr val="FFFFFF"/>
+                </a:solidFill>
+                <a:latin typeface="Arial"/>
+                <a:ea typeface="Arial"/>
+                <a:cs typeface="Arial"/>
+              </a:defRPr>
+            </a:defPPr>
+          </a:lstStyle>
+          <a:p xmlns:a="http://schemas.openxmlformats.org/drawingml/2006/main">
+            <a:pPr algn="ctr">
+              <a:defRPr sz="1763" b="0">
+                <a:solidFill>
+                  <a:srgbClr val="FFFFFF"/>
+                </a:solidFill>
+                <a:latin typeface="Arial"/>
+                <a:ea typeface="Arial"/>
+                <a:cs typeface="Arial"/>
+              </a:defRPr>
+            </a:pPr>
+            <a:r>
+              <a:rPr sz="1763" b="0">
+                <a:solidFill>
+                  <a:srgbClr val="FFFFFF"/>
+                </a:solidFill>
+                <a:latin typeface="Arial"/>
+                <a:ea typeface="Arial"/>
+                <a:cs typeface="Arial"/>
+              </a:rPr>
+              <a:t>mở rộng có điều kiện, khám phá hạch toán khi đủ dữ liệu.</a:t>
+            </a:r>
+          </a:p>
+        </p:txBody>
+      </p:sp>
+      <p:sp>
+        <p:nvSpPr>
+          <p:cNvPr id="36" name="identity">
+            <a:extLst xmlns:a="http://schemas.openxmlformats.org/drawingml/2006/main">
+              <a:ext uri="{FF2B5EF4-FFF2-40B4-BE49-F238E27FC236}">
+                <a16:creationId xmlns:a16="http://schemas.microsoft.com/office/drawing/2014/main" id="{EDF92A7A-7F6C-4D38-ADAC-2B0A9E811FF5}"/>
+              </a:ext>
+            </a:extLst>
+          </p:cNvPr>
+          <p:cNvSpPr>
+            <a:spLocks xmlns:a="http://schemas.openxmlformats.org/drawingml/2006/main" noGrp="1"/>
+          </p:cNvSpPr>
+          <p:nvPr/>
+        </p:nvSpPr>
+        <p:spPr>
+          <a:xfrm xmlns:a="http://schemas.openxmlformats.org/drawingml/2006/main">
+            <a:off x="590550" y="8048625"/>
+            <a:ext cx="13049250" cy="266700"/>
+          </a:xfrm>
+          <a:prstGeom xmlns:a="http://schemas.openxmlformats.org/drawingml/2006/main" prst="rect">
+            <a:avLst/>
+          </a:prstGeom>
+          <a:noFill xmlns:a="http://schemas.openxmlformats.org/drawingml/2006/main"/>
+          <a:ln xmlns:a="http://schemas.openxmlformats.org/drawingml/2006/main" w="0">
+            <a:noFill/>
+          </a:ln>
+        </p:spPr>
+        <p:txBody>
+          <a:bodyPr xmlns:a="http://schemas.openxmlformats.org/drawingml/2006/main" wrap="square" lIns="0" tIns="0" rIns="0" bIns="0" anchor="t">
+            <a:noAutofit/>
+          </a:bodyPr>
+          <a:lstStyle xmlns:a="http://schemas.openxmlformats.org/drawingml/2006/main">
+            <a:defPPr algn="l">
+              <a:defRPr sz="1350" b="0">
+                <a:solidFill>
+                  <a:srgbClr val="3D5481"/>
+                </a:solidFill>
+                <a:latin typeface="Arial"/>
+                <a:ea typeface="Arial"/>
+                <a:cs typeface="Arial"/>
+              </a:defRPr>
+            </a:defPPr>
+          </a:lstStyle>
+          <a:p xmlns:a="http://schemas.openxmlformats.org/drawingml/2006/main">
+            <a:pPr algn="l">
+              <a:defRPr sz="1350" b="0">
+                <a:solidFill>
+                  <a:srgbClr val="3D5481"/>
+                </a:solidFill>
+                <a:latin typeface="Arial"/>
+                <a:ea typeface="Arial"/>
+                <a:cs typeface="Arial"/>
+              </a:defRPr>
+            </a:pPr>
+            <a:r>
+              <a:rPr sz="1350" b="0">
+                <a:solidFill>
+                  <a:srgbClr val="3D5481"/>
+                </a:solidFill>
+                <a:latin typeface="Arial"/>
+                <a:ea typeface="Arial"/>
+                <a:cs typeface="Arial"/>
+              </a:rPr>
+              <a:t>Dương Thị Hồng Viên  ·  2A202602385  ·  VinUni AI Thực Chiến – Cohort IV</a:t>
+            </a:r>
+          </a:p>
+        </p:txBody>
+      </p:sp>
     </p:spTree>
     <p:extLst>
       <p:ext uri="{BB962C8B-B14F-4D97-AF65-F5344CB8AC3E}">
-        <p14:creationId xmlns:p14="http://schemas.microsoft.com/office/powerpoint/2010/main" val="971928341"/>
+        <p14:creationId xmlns:p14="http://schemas.microsoft.com/office/powerpoint/2010/main" val="273899417"/>
       </p:ext>
     </p:extLst>
   </p:cSld>

</xml_diff>

<commit_message>
Audit full Day 13 requirements and align pilot economics, roadmap and slide
</commit_message>
<xml_diff>
--- a/Neiv_CS13_Slide.pptx
+++ b/Neiv_CS13_Slide.pptx
@@ -2,13 +2,13 @@
 <file path=ppt/presentation.xml><?xml version="1.0" encoding="utf-8"?>
 <p:presentation xmlns:p="http://schemas.openxmlformats.org/presentationml/2006/main">
   <p:sldMasterIdLst>
-    <p:sldMasterId xmlns:r="http://schemas.openxmlformats.org/officeDocument/2006/relationships" id="2147483648" r:id="R67359057c3994569"/>
+    <p:sldMasterId xmlns:r="http://schemas.openxmlformats.org/officeDocument/2006/relationships" id="2147483648" r:id="Reb49aa999e364008"/>
   </p:sldMasterIdLst>
   <p:notesMasterIdLst>
-    <p:notesMasterId xmlns:r="http://schemas.openxmlformats.org/officeDocument/2006/relationships" r:id="Rfc23e53a47304ca9"/>
+    <p:notesMasterId xmlns:r="http://schemas.openxmlformats.org/officeDocument/2006/relationships" r:id="R8ebc2c3e5600479f"/>
   </p:notesMasterIdLst>
   <p:sldIdLst>
-    <p:sldId xmlns:r="http://schemas.openxmlformats.org/officeDocument/2006/relationships" id="256" r:id="R113e613e538f4c62"/>
+    <p:sldId xmlns:r="http://schemas.openxmlformats.org/officeDocument/2006/relationships" id="256" r:id="R751348db6630487a"/>
   </p:sldIdLst>
   <p:sldSz cx="15240000" cy="8572500"/>
   <p:notesSz cx="6858000" cy="9144000"/>
@@ -489,7 +489,7 @@
           <p:cNvPr id="3" name="Title">
             <a:extLst xmlns:a="http://schemas.openxmlformats.org/drawingml/2006/main">
               <a:ext uri="{FF2B5EF4-FFF2-40B4-BE49-F238E27FC236}">
-                <a16:creationId xmlns:a16="http://schemas.microsoft.com/office/drawing/2014/main" id="{DAE843B6-B61C-43D7-9FBD-7BAB67C74974}"/>
+                <a16:creationId xmlns:a16="http://schemas.microsoft.com/office/drawing/2014/main" id="{20189A13-B062-41B7-8A5D-36677DA74BE4}"/>
               </a:ext>
             </a:extLst>
           </p:cNvPr>
@@ -646,7 +646,7 @@
           <p:cNvPr id="2" name="Subtitle">
             <a:extLst xmlns:a="http://schemas.openxmlformats.org/drawingml/2006/main">
               <a:ext uri="{FF2B5EF4-FFF2-40B4-BE49-F238E27FC236}">
-                <a16:creationId xmlns:a16="http://schemas.microsoft.com/office/drawing/2014/main" id="{61ABBC5C-17B2-4F0E-8809-25C8EFC87B1C}"/>
+                <a16:creationId xmlns:a16="http://schemas.microsoft.com/office/drawing/2014/main" id="{F96F4E5E-D829-438D-9021-D7180E6182B8}"/>
               </a:ext>
             </a:extLst>
           </p:cNvPr>
@@ -820,7 +820,7 @@
           <p:cNvPr id="2" name="Section title">
             <a:extLst xmlns:a="http://schemas.openxmlformats.org/drawingml/2006/main">
               <a:ext uri="{FF2B5EF4-FFF2-40B4-BE49-F238E27FC236}">
-                <a16:creationId xmlns:a16="http://schemas.microsoft.com/office/drawing/2014/main" id="{B0411941-385F-48AF-B515-E5454E635A28}"/>
+                <a16:creationId xmlns:a16="http://schemas.microsoft.com/office/drawing/2014/main" id="{896B9F38-7C5A-4D2C-AEBD-2643D35BA055}"/>
               </a:ext>
             </a:extLst>
           </p:cNvPr>
@@ -994,7 +994,7 @@
           <p:cNvPr id="3" name="Title">
             <a:extLst xmlns:a="http://schemas.openxmlformats.org/drawingml/2006/main">
               <a:ext uri="{FF2B5EF4-FFF2-40B4-BE49-F238E27FC236}">
-                <a16:creationId xmlns:a16="http://schemas.microsoft.com/office/drawing/2014/main" id="{59E3D6E2-4016-4182-970E-36BEF2EF520F}"/>
+                <a16:creationId xmlns:a16="http://schemas.microsoft.com/office/drawing/2014/main" id="{88D86A2B-6BB7-42CC-AFE3-8D676DE03411}"/>
               </a:ext>
             </a:extLst>
           </p:cNvPr>
@@ -1151,7 +1151,7 @@
           <p:cNvPr id="2" name="Body">
             <a:extLst xmlns:a="http://schemas.openxmlformats.org/drawingml/2006/main">
               <a:ext uri="{FF2B5EF4-FFF2-40B4-BE49-F238E27FC236}">
-                <a16:creationId xmlns:a16="http://schemas.microsoft.com/office/drawing/2014/main" id="{3E48E3EE-DEC6-4D5B-AE03-214E763CEFA7}"/>
+                <a16:creationId xmlns:a16="http://schemas.microsoft.com/office/drawing/2014/main" id="{D4930A47-E9E7-4493-931F-FEADF8729137}"/>
               </a:ext>
             </a:extLst>
           </p:cNvPr>
@@ -1325,7 +1325,7 @@
           <p:cNvPr id="4" name="Title">
             <a:extLst xmlns:a="http://schemas.openxmlformats.org/drawingml/2006/main">
               <a:ext uri="{FF2B5EF4-FFF2-40B4-BE49-F238E27FC236}">
-                <a16:creationId xmlns:a16="http://schemas.microsoft.com/office/drawing/2014/main" id="{07F55161-FB88-4AC4-8AD4-7BD2DAFA63C4}"/>
+                <a16:creationId xmlns:a16="http://schemas.microsoft.com/office/drawing/2014/main" id="{6D35B0CD-08EF-4BE5-8F0E-8E869AC673EF}"/>
               </a:ext>
             </a:extLst>
           </p:cNvPr>
@@ -1482,7 +1482,7 @@
           <p:cNvPr id="2" name="Left column">
             <a:extLst xmlns:a="http://schemas.openxmlformats.org/drawingml/2006/main">
               <a:ext uri="{FF2B5EF4-FFF2-40B4-BE49-F238E27FC236}">
-                <a16:creationId xmlns:a16="http://schemas.microsoft.com/office/drawing/2014/main" id="{5DD51E05-8FF6-4F1D-A660-28944C727617}"/>
+                <a16:creationId xmlns:a16="http://schemas.microsoft.com/office/drawing/2014/main" id="{CBA85B4E-A647-4FEE-B019-93F5502A8906}"/>
               </a:ext>
             </a:extLst>
           </p:cNvPr>
@@ -1639,7 +1639,7 @@
           <p:cNvPr id="3" name="Right column">
             <a:extLst xmlns:a="http://schemas.openxmlformats.org/drawingml/2006/main">
               <a:ext uri="{FF2B5EF4-FFF2-40B4-BE49-F238E27FC236}">
-                <a16:creationId xmlns:a16="http://schemas.microsoft.com/office/drawing/2014/main" id="{E9C5796B-6A50-4005-99A7-75C1D2AE8042}"/>
+                <a16:creationId xmlns:a16="http://schemas.microsoft.com/office/drawing/2014/main" id="{89910CE3-F2B3-41CA-B896-E7425B0AE580}"/>
               </a:ext>
             </a:extLst>
           </p:cNvPr>
@@ -1813,7 +1813,7 @@
           <p:cNvPr id="3" name="Title">
             <a:extLst xmlns:a="http://schemas.openxmlformats.org/drawingml/2006/main">
               <a:ext uri="{FF2B5EF4-FFF2-40B4-BE49-F238E27FC236}">
-                <a16:creationId xmlns:a16="http://schemas.microsoft.com/office/drawing/2014/main" id="{C0EC94A6-52BD-4E03-9E58-3861793D9CA8}"/>
+                <a16:creationId xmlns:a16="http://schemas.microsoft.com/office/drawing/2014/main" id="{BF4EC09D-722D-4F99-BAEA-75A8E2B1FBA1}"/>
               </a:ext>
             </a:extLst>
           </p:cNvPr>
@@ -1970,7 +1970,7 @@
           <p:cNvPr id="2" name="Left column">
             <a:extLst xmlns:a="http://schemas.openxmlformats.org/drawingml/2006/main">
               <a:ext uri="{FF2B5EF4-FFF2-40B4-BE49-F238E27FC236}">
-                <a16:creationId xmlns:a16="http://schemas.microsoft.com/office/drawing/2014/main" id="{871FBADA-28B1-41D6-A016-B18F3C03C036}"/>
+                <a16:creationId xmlns:a16="http://schemas.microsoft.com/office/drawing/2014/main" id="{6B09EA3D-A8A2-446A-ACDD-0273DD539BBA}"/>
               </a:ext>
             </a:extLst>
           </p:cNvPr>
@@ -2165,12 +2165,12 @@
   </p:cSld>
   <p:clrMap bg1="lt1" tx1="dk1" bg2="lt2" tx2="dk2" accent1="accent1" accent2="accent2" accent3="accent3" accent4="accent4" accent5="accent5" accent6="accent6" hlink="hlink" folHlink="folHlink"/>
   <p:sldLayoutIdLst>
-    <p:sldLayoutId xmlns:r="http://schemas.openxmlformats.org/officeDocument/2006/relationships" id="2147483649" r:id="R4aad6d3a81a84e81"/>
-    <p:sldLayoutId xmlns:r="http://schemas.openxmlformats.org/officeDocument/2006/relationships" id="2147483650" r:id="Rdd3f011df2ec49cc"/>
-    <p:sldLayoutId xmlns:r="http://schemas.openxmlformats.org/officeDocument/2006/relationships" id="2147483651" r:id="R96093ecf2cb14b5f"/>
-    <p:sldLayoutId xmlns:r="http://schemas.openxmlformats.org/officeDocument/2006/relationships" id="2147483652" r:id="R42f4abd113e340e4"/>
-    <p:sldLayoutId xmlns:r="http://schemas.openxmlformats.org/officeDocument/2006/relationships" id="2147483653" r:id="Rebf1c90683be4a82"/>
-    <p:sldLayoutId xmlns:r="http://schemas.openxmlformats.org/officeDocument/2006/relationships" id="2147483654" r:id="R6fa477a077fb4a5c"/>
+    <p:sldLayoutId xmlns:r="http://schemas.openxmlformats.org/officeDocument/2006/relationships" id="2147483649" r:id="Rf6b5820115594435"/>
+    <p:sldLayoutId xmlns:r="http://schemas.openxmlformats.org/officeDocument/2006/relationships" id="2147483650" r:id="R5fd2b12dcf7141d2"/>
+    <p:sldLayoutId xmlns:r="http://schemas.openxmlformats.org/officeDocument/2006/relationships" id="2147483651" r:id="Rf4438fa760e644c5"/>
+    <p:sldLayoutId xmlns:r="http://schemas.openxmlformats.org/officeDocument/2006/relationships" id="2147483652" r:id="R088740f3c4314f79"/>
+    <p:sldLayoutId xmlns:r="http://schemas.openxmlformats.org/officeDocument/2006/relationships" id="2147483653" r:id="R8b51e67f31e94f05"/>
+    <p:sldLayoutId xmlns:r="http://schemas.openxmlformats.org/officeDocument/2006/relationships" id="2147483654" r:id="R665ae4f9b94e4ff8"/>
   </p:sldLayoutIdLst>
   <p:txStyles>
     <p:titleStyle>
@@ -2721,7 +2721,7 @@
           <p:cNvPr id="37" name="">
             <a:extLst xmlns:a="http://schemas.openxmlformats.org/drawingml/2006/main">
               <a:ext uri="{FF2B5EF4-FFF2-40B4-BE49-F238E27FC236}">
-                <a16:creationId xmlns:a16="http://schemas.microsoft.com/office/drawing/2014/main" id="{6EB1AF12-6923-4794-8C95-010FE4B5EB99}"/>
+                <a16:creationId xmlns:a16="http://schemas.microsoft.com/office/drawing/2014/main" id="{BEC2B162-A297-4E50-A5BD-3C8D496297B0}"/>
               </a:ext>
             </a:extLst>
           </p:cNvPr>
@@ -2731,7 +2731,7 @@
           <p:nvPr/>
         </p:nvPicPr>
         <p:blipFill>
-          <a:blip xmlns:r="http://schemas.openxmlformats.org/officeDocument/2006/relationships" xmlns:a="http://schemas.openxmlformats.org/drawingml/2006/main" r:embed="R4666eeba3ef34988"/>
+          <a:blip xmlns:r="http://schemas.openxmlformats.org/officeDocument/2006/relationships" xmlns:a="http://schemas.openxmlformats.org/drawingml/2006/main" r:embed="R145845b3213248cf"/>
           <a:stretch xmlns:a="http://schemas.openxmlformats.org/drawingml/2006/main"/>
         </p:blipFill>
         <p:spPr>
@@ -2749,7 +2749,7 @@
           <p:cNvPr id="2" name="course">
             <a:extLst xmlns:a="http://schemas.openxmlformats.org/drawingml/2006/main">
               <a:ext uri="{FF2B5EF4-FFF2-40B4-BE49-F238E27FC236}">
-                <a16:creationId xmlns:a16="http://schemas.microsoft.com/office/drawing/2014/main" id="{7A9F45CE-B174-486D-B4D2-F13CADDB11E2}"/>
+                <a16:creationId xmlns:a16="http://schemas.microsoft.com/office/drawing/2014/main" id="{3BA25604-6DDF-470B-93C9-7488AA78D45F}"/>
               </a:ext>
             </a:extLst>
           </p:cNvPr>
@@ -2817,7 +2817,7 @@
           <p:cNvPr id="3" name="title">
             <a:extLst xmlns:a="http://schemas.openxmlformats.org/drawingml/2006/main">
               <a:ext uri="{FF2B5EF4-FFF2-40B4-BE49-F238E27FC236}">
-                <a16:creationId xmlns:a16="http://schemas.microsoft.com/office/drawing/2014/main" id="{783484B9-DF05-4ED5-A78D-29F2451EC40E}"/>
+                <a16:creationId xmlns:a16="http://schemas.microsoft.com/office/drawing/2014/main" id="{9A06B8BD-C103-4F7B-982C-A6C537B8A373}"/>
               </a:ext>
             </a:extLst>
           </p:cNvPr>
@@ -2885,7 +2885,7 @@
           <p:cNvPr id="4" name="conclusion-border">
             <a:extLst xmlns:a="http://schemas.openxmlformats.org/drawingml/2006/main">
               <a:ext uri="{FF2B5EF4-FFF2-40B4-BE49-F238E27FC236}">
-                <a16:creationId xmlns:a16="http://schemas.microsoft.com/office/drawing/2014/main" id="{5DF52453-A31C-410C-A340-0E149BA83F65}"/>
+                <a16:creationId xmlns:a16="http://schemas.microsoft.com/office/drawing/2014/main" id="{A0B444A0-6AA0-49A3-BBB6-9DA0F797482B}"/>
               </a:ext>
             </a:extLst>
           </p:cNvPr>
@@ -2919,7 +2919,7 @@
           <p:cNvPr id="5" name="conclusion-circle">
             <a:extLst xmlns:a="http://schemas.openxmlformats.org/drawingml/2006/main">
               <a:ext uri="{FF2B5EF4-FFF2-40B4-BE49-F238E27FC236}">
-                <a16:creationId xmlns:a16="http://schemas.microsoft.com/office/drawing/2014/main" id="{2B079B90-DBA3-48CC-8F48-38E6FB4D59BA}"/>
+                <a16:creationId xmlns:a16="http://schemas.microsoft.com/office/drawing/2014/main" id="{F9267DFD-AC24-4549-AE77-BA4165EEEA76}"/>
               </a:ext>
             </a:extLst>
           </p:cNvPr>
@@ -2949,7 +2949,7 @@
           <p:cNvPr id="6" name="conclusion-number">
             <a:extLst xmlns:a="http://schemas.openxmlformats.org/drawingml/2006/main">
               <a:ext uri="{FF2B5EF4-FFF2-40B4-BE49-F238E27FC236}">
-                <a16:creationId xmlns:a16="http://schemas.microsoft.com/office/drawing/2014/main" id="{2A124610-8E25-4DDF-ACD7-FEE65932D83B}"/>
+                <a16:creationId xmlns:a16="http://schemas.microsoft.com/office/drawing/2014/main" id="{343B1F41-2573-488F-B8CD-E847C78623F3}"/>
               </a:ext>
             </a:extLst>
           </p:cNvPr>
@@ -3017,7 +3017,7 @@
           <p:cNvPr id="7" name="conclusion-label">
             <a:extLst xmlns:a="http://schemas.openxmlformats.org/drawingml/2006/main">
               <a:ext uri="{FF2B5EF4-FFF2-40B4-BE49-F238E27FC236}">
-                <a16:creationId xmlns:a16="http://schemas.microsoft.com/office/drawing/2014/main" id="{3E574076-DE17-4798-B4A5-546F800920C9}"/>
+                <a16:creationId xmlns:a16="http://schemas.microsoft.com/office/drawing/2014/main" id="{272D7D71-A4EA-4C48-BC59-C12B17A03913}"/>
               </a:ext>
             </a:extLst>
           </p:cNvPr>
@@ -3085,7 +3085,7 @@
           <p:cNvPr id="8" name="conclusion">
             <a:extLst xmlns:a="http://schemas.openxmlformats.org/drawingml/2006/main">
               <a:ext uri="{FF2B5EF4-FFF2-40B4-BE49-F238E27FC236}">
-                <a16:creationId xmlns:a16="http://schemas.microsoft.com/office/drawing/2014/main" id="{DE99BE04-1B32-4B93-9AD3-734797C66C45}"/>
+                <a16:creationId xmlns:a16="http://schemas.microsoft.com/office/drawing/2014/main" id="{275BCA91-D636-41B3-ADD5-1984582FD4FD}"/>
               </a:ext>
             </a:extLst>
           </p:cNvPr>
@@ -3143,7 +3143,7 @@
                 <a:ea typeface="Arial"/>
                 <a:cs typeface="Arial"/>
               </a:rPr>
-              <a:t>Đề xuất triển khai SổSạch ở Mức 1, duyệt 20% hóa đơn, mục tiêu giảm 50% giờ nhập ảnh. Chỉ lên Mức 2 khi qua cổng chất lượng, rà soát quyết định ngày 90.</a:t>
+              <a:t>Đề xuất thử nghiệm SổSạch cho văn phòng kế toán ở Mức 1 trên 1.000 hóa đơn, duyệt 20%, mục tiêu giảm 50% giờ nhập ảnh và quyết định lên Mức 2 vào ngày 90 nếu qua cổng chất lượng.</a:t>
             </a:r>
           </a:p>
         </p:txBody>
@@ -3153,7 +3153,7 @@
           <p:cNvPr id="9" name="panel-03">
             <a:extLst xmlns:a="http://schemas.openxmlformats.org/drawingml/2006/main">
               <a:ext uri="{FF2B5EF4-FFF2-40B4-BE49-F238E27FC236}">
-                <a16:creationId xmlns:a16="http://schemas.microsoft.com/office/drawing/2014/main" id="{CC3BD93B-20E3-416D-AF66-529810BF3D42}"/>
+                <a16:creationId xmlns:a16="http://schemas.microsoft.com/office/drawing/2014/main" id="{5F282C92-AF2F-4FF3-A408-7004355AA9DB}"/>
               </a:ext>
             </a:extLst>
           </p:cNvPr>
@@ -3165,11 +3165,11 @@
         <p:spPr>
           <a:xfrm xmlns:a="http://schemas.openxmlformats.org/drawingml/2006/main">
             <a:off x="590550" y="2724150"/>
-            <a:ext cx="9001125" cy="1514475"/>
+            <a:ext cx="9001125" cy="1619250"/>
           </a:xfrm>
           <a:prstGeom xmlns:a="http://schemas.openxmlformats.org/drawingml/2006/main" prst="roundRect">
             <a:avLst>
-              <a:gd name="adj" fmla="val 5031"/>
+              <a:gd name="adj" fmla="val 4706"/>
             </a:avLst>
           </a:prstGeom>
           <a:solidFill xmlns:a="http://schemas.openxmlformats.org/drawingml/2006/main">
@@ -3187,7 +3187,7 @@
           <p:cNvPr id="10" name="number-circle-03">
             <a:extLst xmlns:a="http://schemas.openxmlformats.org/drawingml/2006/main">
               <a:ext uri="{FF2B5EF4-FFF2-40B4-BE49-F238E27FC236}">
-                <a16:creationId xmlns:a16="http://schemas.microsoft.com/office/drawing/2014/main" id="{900F2D25-9A51-480F-A726-2EBDAAB85EE1}"/>
+                <a16:creationId xmlns:a16="http://schemas.microsoft.com/office/drawing/2014/main" id="{C119B57D-3955-4CB0-8F5A-B452348C3139}"/>
               </a:ext>
             </a:extLst>
           </p:cNvPr>
@@ -3217,7 +3217,7 @@
           <p:cNvPr id="11" name="number-03">
             <a:extLst xmlns:a="http://schemas.openxmlformats.org/drawingml/2006/main">
               <a:ext uri="{FF2B5EF4-FFF2-40B4-BE49-F238E27FC236}">
-                <a16:creationId xmlns:a16="http://schemas.microsoft.com/office/drawing/2014/main" id="{FDE42700-8031-4656-9B43-2BD0974F185B}"/>
+                <a16:creationId xmlns:a16="http://schemas.microsoft.com/office/drawing/2014/main" id="{2929EE8A-9EC2-4959-9C9F-3100A7917EDD}"/>
               </a:ext>
             </a:extLst>
           </p:cNvPr>
@@ -3285,7 +3285,7 @@
           <p:cNvPr id="12" name="heading-03">
             <a:extLst xmlns:a="http://schemas.openxmlformats.org/drawingml/2006/main">
               <a:ext uri="{FF2B5EF4-FFF2-40B4-BE49-F238E27FC236}">
-                <a16:creationId xmlns:a16="http://schemas.microsoft.com/office/drawing/2014/main" id="{6207A1F3-3D88-4C0F-8738-45BE6017D066}"/>
+                <a16:creationId xmlns:a16="http://schemas.microsoft.com/office/drawing/2014/main" id="{CE26438D-D6D3-440D-B9E0-1D8DF7C81F32}"/>
               </a:ext>
             </a:extLst>
           </p:cNvPr>
@@ -3353,7 +3353,7 @@
           <p:cNvPr id="13" name="body-03">
             <a:extLst xmlns:a="http://schemas.openxmlformats.org/drawingml/2006/main">
               <a:ext uri="{FF2B5EF4-FFF2-40B4-BE49-F238E27FC236}">
-                <a16:creationId xmlns:a16="http://schemas.microsoft.com/office/drawing/2014/main" id="{669B76AA-D97A-44B6-B14B-E388583060C3}"/>
+                <a16:creationId xmlns:a16="http://schemas.microsoft.com/office/drawing/2014/main" id="{ACE7A1A2-1A93-464B-B24B-7639F47AF12F}"/>
               </a:ext>
             </a:extLst>
           </p:cNvPr>
@@ -3365,7 +3365,7 @@
         <p:spPr>
           <a:xfrm xmlns:a="http://schemas.openxmlformats.org/drawingml/2006/main">
             <a:off x="1381125" y="3219450"/>
-            <a:ext cx="7981950" cy="942975"/>
+            <a:ext cx="7981950" cy="1047750"/>
           </a:xfrm>
           <a:prstGeom xmlns:a="http://schemas.openxmlformats.org/drawingml/2006/main" prst="rect">
             <a:avLst/>
@@ -3381,7 +3381,7 @@
           </a:bodyPr>
           <a:lstStyle xmlns:a="http://schemas.openxmlformats.org/drawingml/2006/main">
             <a:defPPr algn="l">
-              <a:defRPr sz="1725" b="0">
+              <a:defRPr sz="1688" b="0">
                 <a:solidFill>
                   <a:srgbClr val="061B60"/>
                 </a:solidFill>
@@ -3393,7 +3393,7 @@
           </a:lstStyle>
           <a:p xmlns:a="http://schemas.openxmlformats.org/drawingml/2006/main">
             <a:pPr algn="l">
-              <a:defRPr sz="1725" b="0">
+              <a:defRPr sz="1688" b="0">
                 <a:solidFill>
                   <a:srgbClr val="061B60"/>
                 </a:solidFill>
@@ -3403,7 +3403,7 @@
               </a:defRPr>
             </a:pPr>
             <a:r>
-              <a:rPr sz="1725" b="0">
+              <a:rPr sz="1688" b="0">
                 <a:solidFill>
                   <a:srgbClr val="061B60"/>
                 </a:solidFill>
@@ -3411,7 +3411,7 @@
                 <a:ea typeface="Arial"/>
                 <a:cs typeface="Arial"/>
               </a:rPr>
-              <a:t>Cần bộ đề 40 hóa đơn, quyền dùng dữ liệu và kết nối phần mềm. Chị Hạnh tối đa 3 giờ/tuần, anh Tùng hỗ trợ chấm. Công ty bố trí 60 giờ duyệt/tháng cho 12.000 hóa đơn. Mức 1: 704 đồng/việc, biên gộp 68,79% theo giả định đề.</a:t>
+              <a:t>Cần bộ đề 40 hóa đơn, quyền dữ liệu và kết nối phần mềm. Hạnh tối đa 3 giờ/tuần, Tùng hỗ trợ chấm. Công ty cần 5 giờ duyệt/1.000 hóa đơn, chi phí dự kiến 704.000 đồng. Biên 68,79% chỉ theo bình quân đề. Phí tích hợp cần duyệt riêng.</a:t>
             </a:r>
           </a:p>
         </p:txBody>
@@ -3421,7 +3421,7 @@
           <p:cNvPr id="14" name="panel-04">
             <a:extLst xmlns:a="http://schemas.openxmlformats.org/drawingml/2006/main">
               <a:ext uri="{FF2B5EF4-FFF2-40B4-BE49-F238E27FC236}">
-                <a16:creationId xmlns:a16="http://schemas.microsoft.com/office/drawing/2014/main" id="{F8F699BD-3188-4177-A276-7172DB142E0D}"/>
+                <a16:creationId xmlns:a16="http://schemas.microsoft.com/office/drawing/2014/main" id="{1E4193EA-9465-4606-BDFA-FEEB1B624D84}"/>
               </a:ext>
             </a:extLst>
           </p:cNvPr>
@@ -3432,12 +3432,12 @@
         </p:nvSpPr>
         <p:spPr>
           <a:xfrm xmlns:a="http://schemas.openxmlformats.org/drawingml/2006/main">
-            <a:off x="590550" y="4391025"/>
-            <a:ext cx="9001125" cy="1552575"/>
+            <a:off x="590550" y="4495800"/>
+            <a:ext cx="9001125" cy="1619250"/>
           </a:xfrm>
           <a:prstGeom xmlns:a="http://schemas.openxmlformats.org/drawingml/2006/main" prst="roundRect">
             <a:avLst>
-              <a:gd name="adj" fmla="val 4908"/>
+              <a:gd name="adj" fmla="val 4706"/>
             </a:avLst>
           </a:prstGeom>
           <a:solidFill xmlns:a="http://schemas.openxmlformats.org/drawingml/2006/main">
@@ -3455,7 +3455,7 @@
           <p:cNvPr id="15" name="number-circle-04">
             <a:extLst xmlns:a="http://schemas.openxmlformats.org/drawingml/2006/main">
               <a:ext uri="{FF2B5EF4-FFF2-40B4-BE49-F238E27FC236}">
-                <a16:creationId xmlns:a16="http://schemas.microsoft.com/office/drawing/2014/main" id="{16E2FFFF-729E-4EC2-A367-31BEAE365A46}"/>
+                <a16:creationId xmlns:a16="http://schemas.microsoft.com/office/drawing/2014/main" id="{F26BBE13-5077-406C-A302-BFED0D7B5A08}"/>
               </a:ext>
             </a:extLst>
           </p:cNvPr>
@@ -3466,7 +3466,7 @@
         </p:nvSpPr>
         <p:spPr>
           <a:xfrm xmlns:a="http://schemas.openxmlformats.org/drawingml/2006/main">
-            <a:off x="742950" y="4533900"/>
+            <a:off x="742950" y="4638675"/>
             <a:ext cx="466725" cy="466725"/>
           </a:xfrm>
           <a:prstGeom xmlns:a="http://schemas.openxmlformats.org/drawingml/2006/main" prst="ellipse">
@@ -3485,7 +3485,7 @@
           <p:cNvPr id="16" name="number-04">
             <a:extLst xmlns:a="http://schemas.openxmlformats.org/drawingml/2006/main">
               <a:ext uri="{FF2B5EF4-FFF2-40B4-BE49-F238E27FC236}">
-                <a16:creationId xmlns:a16="http://schemas.microsoft.com/office/drawing/2014/main" id="{126280BE-8C0D-4C17-9E0C-CA9D916A9B87}"/>
+                <a16:creationId xmlns:a16="http://schemas.microsoft.com/office/drawing/2014/main" id="{EA8032A1-10A2-41F6-91BC-34DCD351A4F2}"/>
               </a:ext>
             </a:extLst>
           </p:cNvPr>
@@ -3496,7 +3496,7 @@
         </p:nvSpPr>
         <p:spPr>
           <a:xfrm xmlns:a="http://schemas.openxmlformats.org/drawingml/2006/main">
-            <a:off x="742950" y="4638675"/>
+            <a:off x="742950" y="4743450"/>
             <a:ext cx="466725" cy="285750"/>
           </a:xfrm>
           <a:prstGeom xmlns:a="http://schemas.openxmlformats.org/drawingml/2006/main" prst="rect">
@@ -3553,7 +3553,7 @@
           <p:cNvPr id="17" name="heading-04">
             <a:extLst xmlns:a="http://schemas.openxmlformats.org/drawingml/2006/main">
               <a:ext uri="{FF2B5EF4-FFF2-40B4-BE49-F238E27FC236}">
-                <a16:creationId xmlns:a16="http://schemas.microsoft.com/office/drawing/2014/main" id="{81FBB144-F843-421E-ACAD-9D8C096D7B5D}"/>
+                <a16:creationId xmlns:a16="http://schemas.microsoft.com/office/drawing/2014/main" id="{1E321080-0612-4CE2-9EE6-1DFF6A2C74EE}"/>
               </a:ext>
             </a:extLst>
           </p:cNvPr>
@@ -3564,7 +3564,7 @@
         </p:nvSpPr>
         <p:spPr>
           <a:xfrm xmlns:a="http://schemas.openxmlformats.org/drawingml/2006/main">
-            <a:off x="1381125" y="4514850"/>
+            <a:off x="1381125" y="4619625"/>
             <a:ext cx="7715250" cy="304800"/>
           </a:xfrm>
           <a:prstGeom xmlns:a="http://schemas.openxmlformats.org/drawingml/2006/main" prst="rect">
@@ -3621,7 +3621,7 @@
           <p:cNvPr id="18" name="body-04">
             <a:extLst xmlns:a="http://schemas.openxmlformats.org/drawingml/2006/main">
               <a:ext uri="{FF2B5EF4-FFF2-40B4-BE49-F238E27FC236}">
-                <a16:creationId xmlns:a16="http://schemas.microsoft.com/office/drawing/2014/main" id="{F054D139-34C6-463B-93BF-F4654D49BA95}"/>
+                <a16:creationId xmlns:a16="http://schemas.microsoft.com/office/drawing/2014/main" id="{803AF960-DC8D-4B64-9386-6F69464D199B}"/>
               </a:ext>
             </a:extLst>
           </p:cNvPr>
@@ -3632,8 +3632,8 @@
         </p:nvSpPr>
         <p:spPr>
           <a:xfrm xmlns:a="http://schemas.openxmlformats.org/drawingml/2006/main">
-            <a:off x="1381125" y="4886325"/>
-            <a:ext cx="7981950" cy="981075"/>
+            <a:off x="1381125" y="4991100"/>
+            <a:ext cx="7981950" cy="1047750"/>
           </a:xfrm>
           <a:prstGeom xmlns:a="http://schemas.openxmlformats.org/drawingml/2006/main" prst="rect">
             <a:avLst/>
@@ -3649,7 +3649,7 @@
           </a:bodyPr>
           <a:lstStyle xmlns:a="http://schemas.openxmlformats.org/drawingml/2006/main">
             <a:defPPr algn="l">
-              <a:defRPr sz="1725" b="0">
+              <a:defRPr sz="1650" b="0">
                 <a:solidFill>
                   <a:srgbClr val="061B60"/>
                 </a:solidFill>
@@ -3661,7 +3661,7 @@
           </a:lstStyle>
           <a:p xmlns:a="http://schemas.openxmlformats.org/drawingml/2006/main">
             <a:pPr algn="l">
-              <a:defRPr sz="1725" b="0">
+              <a:defRPr sz="1650" b="0">
                 <a:solidFill>
                   <a:srgbClr val="061B60"/>
                 </a:solidFill>
@@ -3671,7 +3671,7 @@
               </a:defRPr>
             </a:pPr>
             <a:r>
-              <a:rPr sz="1725" b="0">
+              <a:rPr sz="1650" b="0">
                 <a:solidFill>
                   <a:srgbClr val="061B60"/>
                 </a:solidFill>
@@ -3679,7 +3679,7 @@
                 <a:ea typeface="Arial"/>
                 <a:cs typeface="Arial"/>
               </a:rPr>
-              <a:t>Sai mã số thuế hoặc tiền: ngừng tự nhập ngay. Duyệt mọi cờ và lấy mẫu. Nếu doanh thu dưới 3,71 triệu/văn phòng trong 2 tháng, với ít nhất 10 văn phòng, dừng mở rộng. Chưa đủ mẫu thì giữ thử nghiệm, lưu ý kịch bản hết tiền tháng 7.</a:t>
+              <a:t>Rủi ro lớn nhất: 65% doanh thu từ 30% văn phòng. Theo dõi từ thử nghiệm, dừng mở rộng nếu doanh thu dưới 3,71 triệu/văn phòng trong 2 tháng liên tiếp trên ít nhất 10 văn phòng. Chưa đủ mẫu thì giữ thử nghiệm. Kịch bản xấu hết tiền tháng 7.</a:t>
             </a:r>
           </a:p>
         </p:txBody>
@@ -3689,7 +3689,7 @@
           <p:cNvPr id="19" name="panel-05">
             <a:extLst xmlns:a="http://schemas.openxmlformats.org/drawingml/2006/main">
               <a:ext uri="{FF2B5EF4-FFF2-40B4-BE49-F238E27FC236}">
-                <a16:creationId xmlns:a16="http://schemas.microsoft.com/office/drawing/2014/main" id="{CBEE3573-5A45-43AD-8243-718B26C7F6BD}"/>
+                <a16:creationId xmlns:a16="http://schemas.microsoft.com/office/drawing/2014/main" id="{B5C1519F-11CE-485F-BE0F-E54003FBE0FC}"/>
               </a:ext>
             </a:extLst>
           </p:cNvPr>
@@ -3700,12 +3700,12 @@
         </p:nvSpPr>
         <p:spPr>
           <a:xfrm xmlns:a="http://schemas.openxmlformats.org/drawingml/2006/main">
-            <a:off x="590550" y="6096000"/>
-            <a:ext cx="9001125" cy="1628775"/>
+            <a:off x="590550" y="6267450"/>
+            <a:ext cx="9001125" cy="1457325"/>
           </a:xfrm>
           <a:prstGeom xmlns:a="http://schemas.openxmlformats.org/drawingml/2006/main" prst="roundRect">
             <a:avLst>
-              <a:gd name="adj" fmla="val 4678"/>
+              <a:gd name="adj" fmla="val 5229"/>
             </a:avLst>
           </a:prstGeom>
           <a:solidFill xmlns:a="http://schemas.openxmlformats.org/drawingml/2006/main">
@@ -3723,7 +3723,7 @@
           <p:cNvPr id="20" name="number-circle-05">
             <a:extLst xmlns:a="http://schemas.openxmlformats.org/drawingml/2006/main">
               <a:ext uri="{FF2B5EF4-FFF2-40B4-BE49-F238E27FC236}">
-                <a16:creationId xmlns:a16="http://schemas.microsoft.com/office/drawing/2014/main" id="{D59B71FE-8200-46BE-9386-66E80237AD04}"/>
+                <a16:creationId xmlns:a16="http://schemas.microsoft.com/office/drawing/2014/main" id="{742C7170-2FB1-41B6-A56B-AD12FA290290}"/>
               </a:ext>
             </a:extLst>
           </p:cNvPr>
@@ -3734,7 +3734,7 @@
         </p:nvSpPr>
         <p:spPr>
           <a:xfrm xmlns:a="http://schemas.openxmlformats.org/drawingml/2006/main">
-            <a:off x="742950" y="6238875"/>
+            <a:off x="742950" y="6410325"/>
             <a:ext cx="466725" cy="466725"/>
           </a:xfrm>
           <a:prstGeom xmlns:a="http://schemas.openxmlformats.org/drawingml/2006/main" prst="ellipse">
@@ -3753,7 +3753,7 @@
           <p:cNvPr id="21" name="number-05">
             <a:extLst xmlns:a="http://schemas.openxmlformats.org/drawingml/2006/main">
               <a:ext uri="{FF2B5EF4-FFF2-40B4-BE49-F238E27FC236}">
-                <a16:creationId xmlns:a16="http://schemas.microsoft.com/office/drawing/2014/main" id="{188C7F16-4285-4E6F-A56D-61E66EF4F901}"/>
+                <a16:creationId xmlns:a16="http://schemas.microsoft.com/office/drawing/2014/main" id="{8DF12F96-7FE5-4016-B7AC-867E152F633C}"/>
               </a:ext>
             </a:extLst>
           </p:cNvPr>
@@ -3764,7 +3764,7 @@
         </p:nvSpPr>
         <p:spPr>
           <a:xfrm xmlns:a="http://schemas.openxmlformats.org/drawingml/2006/main">
-            <a:off x="742950" y="6343650"/>
+            <a:off x="742950" y="6515100"/>
             <a:ext cx="466725" cy="285750"/>
           </a:xfrm>
           <a:prstGeom xmlns:a="http://schemas.openxmlformats.org/drawingml/2006/main" prst="rect">
@@ -3821,7 +3821,7 @@
           <p:cNvPr id="22" name="heading-05">
             <a:extLst xmlns:a="http://schemas.openxmlformats.org/drawingml/2006/main">
               <a:ext uri="{FF2B5EF4-FFF2-40B4-BE49-F238E27FC236}">
-                <a16:creationId xmlns:a16="http://schemas.microsoft.com/office/drawing/2014/main" id="{B472D5C5-E976-4C1C-83D8-23E463904D73}"/>
+                <a16:creationId xmlns:a16="http://schemas.microsoft.com/office/drawing/2014/main" id="{3843B445-F469-459B-90ED-F67626A1D20F}"/>
               </a:ext>
             </a:extLst>
           </p:cNvPr>
@@ -3832,7 +3832,7 @@
         </p:nvSpPr>
         <p:spPr>
           <a:xfrm xmlns:a="http://schemas.openxmlformats.org/drawingml/2006/main">
-            <a:off x="1381125" y="6219825"/>
+            <a:off x="1381125" y="6391275"/>
             <a:ext cx="7715250" cy="304800"/>
           </a:xfrm>
           <a:prstGeom xmlns:a="http://schemas.openxmlformats.org/drawingml/2006/main" prst="rect">
@@ -3889,7 +3889,7 @@
           <p:cNvPr id="23" name="body-05">
             <a:extLst xmlns:a="http://schemas.openxmlformats.org/drawingml/2006/main">
               <a:ext uri="{FF2B5EF4-FFF2-40B4-BE49-F238E27FC236}">
-                <a16:creationId xmlns:a16="http://schemas.microsoft.com/office/drawing/2014/main" id="{A0DDF751-3788-46E1-B8E1-64CCC0C9C2C4}"/>
+                <a16:creationId xmlns:a16="http://schemas.microsoft.com/office/drawing/2014/main" id="{D9F1A82B-75D2-4298-B19A-7BDE09AC6A8C}"/>
               </a:ext>
             </a:extLst>
           </p:cNvPr>
@@ -3900,8 +3900,8 @@
         </p:nvSpPr>
         <p:spPr>
           <a:xfrm xmlns:a="http://schemas.openxmlformats.org/drawingml/2006/main">
-            <a:off x="1381125" y="6591300"/>
-            <a:ext cx="7981950" cy="1057275"/>
+            <a:off x="1381125" y="6762750"/>
+            <a:ext cx="7981950" cy="885825"/>
           </a:xfrm>
           <a:prstGeom xmlns:a="http://schemas.openxmlformats.org/drawingml/2006/main" prst="rect">
             <a:avLst/>
@@ -3917,7 +3917,7 @@
           </a:bodyPr>
           <a:lstStyle xmlns:a="http://schemas.openxmlformats.org/drawingml/2006/main">
             <a:defPPr algn="l">
-              <a:defRPr sz="1725" b="0">
+              <a:defRPr sz="1688" b="0">
                 <a:solidFill>
                   <a:srgbClr val="061B60"/>
                 </a:solidFill>
@@ -3929,7 +3929,7 @@
           </a:lstStyle>
           <a:p xmlns:a="http://schemas.openxmlformats.org/drawingml/2006/main">
             <a:pPr algn="l">
-              <a:defRPr sz="1725" b="0">
+              <a:defRPr sz="1688" b="0">
                 <a:solidFill>
                   <a:srgbClr val="061B60"/>
                 </a:solidFill>
@@ -3939,7 +3939,7 @@
               </a:defRPr>
             </a:pPr>
             <a:r>
-              <a:rPr sz="1725" b="0">
+              <a:rPr sz="1688" b="0">
                 <a:solidFill>
                   <a:srgbClr val="061B60"/>
                 </a:solidFill>
@@ -3947,7 +3947,7 @@
                 <a:ea typeface="Arial"/>
                 <a:cs typeface="Arial"/>
               </a:rPr>
-              <a:t>Ngày 30/60/90 từ lúc bắt đầu: xem lỗi, cờ thừa, giờ nhập và chi phí. Mức 2 cần 0 lỗi nghiêm trọng/300 hóa đơn kiểm tra, đạt từ 95%, không tầng tụt. Mô hình, giá hoặc quy định đổi: rà soát ngay. Các ngưỡng mới là đề xuất cần kiểm chứng.</a:t>
+              <a:t>Ngày 30/60/90 và khi mô hình, giá hoặc quy định đổi: rà soát. Mức 2 cần đạt từ 95%, không tầng tụt, 0 lỗi nghiêm trọng/300 hóa đơn kiểm. Có 1 lỗi mã số thuế/tiền: ngừng tự nhập ngay. Ngưỡng mới cần kiểm chứng.</a:t>
             </a:r>
           </a:p>
         </p:txBody>
@@ -3957,7 +3957,7 @@
           <p:cNvPr id="24" name="roadmap-heading">
             <a:extLst xmlns:a="http://schemas.openxmlformats.org/drawingml/2006/main">
               <a:ext uri="{FF2B5EF4-FFF2-40B4-BE49-F238E27FC236}">
-                <a16:creationId xmlns:a16="http://schemas.microsoft.com/office/drawing/2014/main" id="{F6F6C050-4417-43D9-883F-41CCCC3DF481}"/>
+                <a16:creationId xmlns:a16="http://schemas.microsoft.com/office/drawing/2014/main" id="{1FC09BB8-8CA5-4535-9540-87D4F0469532}"/>
               </a:ext>
             </a:extLst>
           </p:cNvPr>
@@ -4025,7 +4025,7 @@
           <p:cNvPr id="25" name="stage-0">
             <a:extLst xmlns:a="http://schemas.openxmlformats.org/drawingml/2006/main">
               <a:ext uri="{FF2B5EF4-FFF2-40B4-BE49-F238E27FC236}">
-                <a16:creationId xmlns:a16="http://schemas.microsoft.com/office/drawing/2014/main" id="{CC2A97D1-D8BB-40EE-9ED7-CDC1B1C57A07}"/>
+                <a16:creationId xmlns:a16="http://schemas.microsoft.com/office/drawing/2014/main" id="{563F86DD-2FEB-43D9-91D6-38608828AC98}"/>
               </a:ext>
             </a:extLst>
           </p:cNvPr>
@@ -4057,7 +4057,7 @@
           <p:cNvPr id="26" name="stage-period-0">
             <a:extLst xmlns:a="http://schemas.openxmlformats.org/drawingml/2006/main">
               <a:ext uri="{FF2B5EF4-FFF2-40B4-BE49-F238E27FC236}">
-                <a16:creationId xmlns:a16="http://schemas.microsoft.com/office/drawing/2014/main" id="{F4A6FD50-1F54-44B0-8B8C-21867F653330}"/>
+                <a16:creationId xmlns:a16="http://schemas.microsoft.com/office/drawing/2014/main" id="{806DD89E-D99B-43AA-A2EB-B1C8E1E01BED}"/>
               </a:ext>
             </a:extLst>
           </p:cNvPr>
@@ -4125,7 +4125,7 @@
           <p:cNvPr id="27" name="stage-body-0">
             <a:extLst xmlns:a="http://schemas.openxmlformats.org/drawingml/2006/main">
               <a:ext uri="{FF2B5EF4-FFF2-40B4-BE49-F238E27FC236}">
-                <a16:creationId xmlns:a16="http://schemas.microsoft.com/office/drawing/2014/main" id="{C427823A-48E9-46DE-9276-670A7F6F791D}"/>
+                <a16:creationId xmlns:a16="http://schemas.microsoft.com/office/drawing/2014/main" id="{E55109EE-8DB7-4F65-8EB1-43494ED2A621}"/>
               </a:ext>
             </a:extLst>
           </p:cNvPr>
@@ -4183,7 +4183,7 @@
                 <a:ea typeface="Arial"/>
                 <a:cs typeface="Arial"/>
               </a:rPr>
-              <a:t>đọc ảnh và gắn cờ.</a:t>
+              <a:t>đọc ảnh, gắn cờ và đối chiếu mã số thuế.</a:t>
             </a:r>
           </a:p>
         </p:txBody>
@@ -4193,7 +4193,7 @@
           <p:cNvPr id="28" name="stage-connector-0">
             <a:extLst xmlns:a="http://schemas.openxmlformats.org/drawingml/2006/main">
               <a:ext uri="{FF2B5EF4-FFF2-40B4-BE49-F238E27FC236}">
-                <a16:creationId xmlns:a16="http://schemas.microsoft.com/office/drawing/2014/main" id="{64DCEF97-4E08-4A30-AA12-9A1837082D45}"/>
+                <a16:creationId xmlns:a16="http://schemas.microsoft.com/office/drawing/2014/main" id="{D0F16E25-C7DB-4301-893E-CBB4F73C12BA}"/>
               </a:ext>
             </a:extLst>
           </p:cNvPr>
@@ -4223,7 +4223,7 @@
           <p:cNvPr id="29" name="stage-1">
             <a:extLst xmlns:a="http://schemas.openxmlformats.org/drawingml/2006/main">
               <a:ext uri="{FF2B5EF4-FFF2-40B4-BE49-F238E27FC236}">
-                <a16:creationId xmlns:a16="http://schemas.microsoft.com/office/drawing/2014/main" id="{D3AB1651-C71E-4211-8239-B64B1C8371B8}"/>
+                <a16:creationId xmlns:a16="http://schemas.microsoft.com/office/drawing/2014/main" id="{0740F7E6-A007-4B04-A510-22AA9F384C00}"/>
               </a:ext>
             </a:extLst>
           </p:cNvPr>
@@ -4255,7 +4255,7 @@
           <p:cNvPr id="30" name="stage-period-1">
             <a:extLst xmlns:a="http://schemas.openxmlformats.org/drawingml/2006/main">
               <a:ext uri="{FF2B5EF4-FFF2-40B4-BE49-F238E27FC236}">
-                <a16:creationId xmlns:a16="http://schemas.microsoft.com/office/drawing/2014/main" id="{EAA0B83E-507B-49B8-8828-B06F90005FA2}"/>
+                <a16:creationId xmlns:a16="http://schemas.microsoft.com/office/drawing/2014/main" id="{E98659A1-E2E7-42E5-A373-BB7752A252D3}"/>
               </a:ext>
             </a:extLst>
           </p:cNvPr>
@@ -4323,7 +4323,7 @@
           <p:cNvPr id="31" name="stage-body-1">
             <a:extLst xmlns:a="http://schemas.openxmlformats.org/drawingml/2006/main">
               <a:ext uri="{FF2B5EF4-FFF2-40B4-BE49-F238E27FC236}">
-                <a16:creationId xmlns:a16="http://schemas.microsoft.com/office/drawing/2014/main" id="{B34CB3F9-0D40-4C40-8E56-9EB53D8E0DE6}"/>
+                <a16:creationId xmlns:a16="http://schemas.microsoft.com/office/drawing/2014/main" id="{CF3D7880-3C4F-424C-848E-B0FA28D1CDCD}"/>
               </a:ext>
             </a:extLst>
           </p:cNvPr>
@@ -4381,7 +4381,7 @@
                 <a:ea typeface="Arial"/>
                 <a:cs typeface="Arial"/>
               </a:rPr>
-              <a:t>đối chiếu mã số thuế, tích hợp dịch vụ sẵn có.</a:t>
+              <a:t>giảm tỷ lệ duyệt sau cổng Mức 2.</a:t>
             </a:r>
           </a:p>
         </p:txBody>
@@ -4391,7 +4391,7 @@
           <p:cNvPr id="32" name="stage-connector-1">
             <a:extLst xmlns:a="http://schemas.openxmlformats.org/drawingml/2006/main">
               <a:ext uri="{FF2B5EF4-FFF2-40B4-BE49-F238E27FC236}">
-                <a16:creationId xmlns:a16="http://schemas.microsoft.com/office/drawing/2014/main" id="{4E464F5C-F402-4B7E-AC32-D1C9739ECD0C}"/>
+                <a16:creationId xmlns:a16="http://schemas.microsoft.com/office/drawing/2014/main" id="{0E4F5FC2-10D9-4F00-A063-83D313D54093}"/>
               </a:ext>
             </a:extLst>
           </p:cNvPr>
@@ -4421,7 +4421,7 @@
           <p:cNvPr id="33" name="stage-2">
             <a:extLst xmlns:a="http://schemas.openxmlformats.org/drawingml/2006/main">
               <a:ext uri="{FF2B5EF4-FFF2-40B4-BE49-F238E27FC236}">
-                <a16:creationId xmlns:a16="http://schemas.microsoft.com/office/drawing/2014/main" id="{987F2A08-6EAD-44EB-B0CD-E2D1A7BA9418}"/>
+                <a16:creationId xmlns:a16="http://schemas.microsoft.com/office/drawing/2014/main" id="{EF76FA58-868F-4B11-8BC7-BB0C208AD839}"/>
               </a:ext>
             </a:extLst>
           </p:cNvPr>
@@ -4453,7 +4453,7 @@
           <p:cNvPr id="34" name="stage-period-2">
             <a:extLst xmlns:a="http://schemas.openxmlformats.org/drawingml/2006/main">
               <a:ext uri="{FF2B5EF4-FFF2-40B4-BE49-F238E27FC236}">
-                <a16:creationId xmlns:a16="http://schemas.microsoft.com/office/drawing/2014/main" id="{068B125F-1EC6-4D73-BD5E-DBF320A6C088}"/>
+                <a16:creationId xmlns:a16="http://schemas.microsoft.com/office/drawing/2014/main" id="{1B94317D-3A3E-43E3-9D93-D01E5714633A}"/>
               </a:ext>
             </a:extLst>
           </p:cNvPr>
@@ -4521,7 +4521,7 @@
           <p:cNvPr id="35" name="stage-body-2">
             <a:extLst xmlns:a="http://schemas.openxmlformats.org/drawingml/2006/main">
               <a:ext uri="{FF2B5EF4-FFF2-40B4-BE49-F238E27FC236}">
-                <a16:creationId xmlns:a16="http://schemas.microsoft.com/office/drawing/2014/main" id="{5DC09209-B3E1-4CCE-A777-CBDE0A797041}"/>
+                <a16:creationId xmlns:a16="http://schemas.microsoft.com/office/drawing/2014/main" id="{BE651611-75B1-401D-BC2E-388174A04C4C}"/>
               </a:ext>
             </a:extLst>
           </p:cNvPr>
@@ -4589,7 +4589,7 @@
           <p:cNvPr id="36" name="identity">
             <a:extLst xmlns:a="http://schemas.openxmlformats.org/drawingml/2006/main">
               <a:ext uri="{FF2B5EF4-FFF2-40B4-BE49-F238E27FC236}">
-                <a16:creationId xmlns:a16="http://schemas.microsoft.com/office/drawing/2014/main" id="{EDF92A7A-7F6C-4D38-ADAC-2B0A9E811FF5}"/>
+                <a16:creationId xmlns:a16="http://schemas.microsoft.com/office/drawing/2014/main" id="{635B81A9-D2A8-4C98-AD2F-10DD0CD737E0}"/>
               </a:ext>
             </a:extLst>
           </p:cNvPr>
@@ -4655,7 +4655,7 @@
     </p:spTree>
     <p:extLst>
       <p:ext uri="{BB962C8B-B14F-4D97-AF65-F5344CB8AC3E}">
-        <p14:creationId xmlns:p14="http://schemas.microsoft.com/office/powerpoint/2010/main" val="273899417"/>
+        <p14:creationId xmlns:p14="http://schemas.microsoft.com/office/powerpoint/2010/main" val="1720074408"/>
       </p:ext>
     </p:extLst>
   </p:cSld>

</xml_diff>